<commit_message>
Correct pilot language availability
</commit_message>
<xml_diff>
--- a/docs/presentation/HeatSafe_Business_Model_Branded.pptx
+++ b/docs/presentation/HeatSafe_Business_Model_Branded.pptx
@@ -2,22 +2,22 @@
 <file path=ppt/presentation.xml><?xml version="1.0" encoding="utf-8"?>
 <p:presentation xmlns:p="http://schemas.openxmlformats.org/presentationml/2006/main">
   <p:sldMasterIdLst>
-    <p:sldMasterId xmlns:r="http://schemas.openxmlformats.org/officeDocument/2006/relationships" id="2147483648" r:id="Ra9f6f9274bdc449d"/>
+    <p:sldMasterId xmlns:r="http://schemas.openxmlformats.org/officeDocument/2006/relationships" id="2147483648" r:id="R66889a80247745a4"/>
   </p:sldMasterIdLst>
   <p:notesMasterIdLst>
-    <p:notesMasterId xmlns:r="http://schemas.openxmlformats.org/officeDocument/2006/relationships" r:id="Rec556f6cec7b4380"/>
+    <p:notesMasterId xmlns:r="http://schemas.openxmlformats.org/officeDocument/2006/relationships" r:id="Rc3d4264c9c1a4293"/>
   </p:notesMasterIdLst>
   <p:sldIdLst>
-    <p:sldId xmlns:r="http://schemas.openxmlformats.org/officeDocument/2006/relationships" id="256" r:id="R502e067101de45e3"/>
-    <p:sldId xmlns:r="http://schemas.openxmlformats.org/officeDocument/2006/relationships" id="257" r:id="R890ff4bab1a147e7"/>
-    <p:sldId xmlns:r="http://schemas.openxmlformats.org/officeDocument/2006/relationships" id="258" r:id="R06e7d958cffc4a0a"/>
-    <p:sldId xmlns:r="http://schemas.openxmlformats.org/officeDocument/2006/relationships" id="259" r:id="R80870a7818114258"/>
-    <p:sldId xmlns:r="http://schemas.openxmlformats.org/officeDocument/2006/relationships" id="260" r:id="R9e0d18a40cab4823"/>
-    <p:sldId xmlns:r="http://schemas.openxmlformats.org/officeDocument/2006/relationships" id="261" r:id="Rb9d52bb7dfe743b9"/>
-    <p:sldId xmlns:r="http://schemas.openxmlformats.org/officeDocument/2006/relationships" id="262" r:id="R890fe118c4974a3a"/>
-    <p:sldId xmlns:r="http://schemas.openxmlformats.org/officeDocument/2006/relationships" id="263" r:id="R1962253de7434d59"/>
-    <p:sldId xmlns:r="http://schemas.openxmlformats.org/officeDocument/2006/relationships" id="264" r:id="Rd34a4cb6402d4587"/>
-    <p:sldId xmlns:r="http://schemas.openxmlformats.org/officeDocument/2006/relationships" id="265" r:id="R433157ed4d9241bc"/>
+    <p:sldId xmlns:r="http://schemas.openxmlformats.org/officeDocument/2006/relationships" id="256" r:id="Rd6aa0bdde66e4ac3"/>
+    <p:sldId xmlns:r="http://schemas.openxmlformats.org/officeDocument/2006/relationships" id="257" r:id="Rd65bad9fff4c4917"/>
+    <p:sldId xmlns:r="http://schemas.openxmlformats.org/officeDocument/2006/relationships" id="258" r:id="R3b6685afbea14e88"/>
+    <p:sldId xmlns:r="http://schemas.openxmlformats.org/officeDocument/2006/relationships" id="259" r:id="R7c0e12640f3241c9"/>
+    <p:sldId xmlns:r="http://schemas.openxmlformats.org/officeDocument/2006/relationships" id="260" r:id="R6ef5927595d1420b"/>
+    <p:sldId xmlns:r="http://schemas.openxmlformats.org/officeDocument/2006/relationships" id="261" r:id="R1cfda52715e34012"/>
+    <p:sldId xmlns:r="http://schemas.openxmlformats.org/officeDocument/2006/relationships" id="262" r:id="Rfb20379ab5fe46a3"/>
+    <p:sldId xmlns:r="http://schemas.openxmlformats.org/officeDocument/2006/relationships" id="263" r:id="Ree0cf4e562374661"/>
+    <p:sldId xmlns:r="http://schemas.openxmlformats.org/officeDocument/2006/relationships" id="264" r:id="R52a8106e4a50488b"/>
+    <p:sldId xmlns:r="http://schemas.openxmlformats.org/officeDocument/2006/relationships" id="265" r:id="Ra08ba1c8b57a462a"/>
   </p:sldIdLst>
   <p:sldSz cx="12192000" cy="6858000"/>
   <p:notesSz cx="6858000" cy="9144000"/>
@@ -1360,8 +1360,8 @@
   </p:cSld>
   <p:clrMap bg1="lt1" tx1="dk1" bg2="lt2" tx2="dk2" accent1="accent1" accent2="accent2" accent3="accent3" accent4="accent4" accent5="accent5" accent6="accent6" hlink="hlink" folHlink="folHlink"/>
   <p:sldLayoutIdLst>
-    <p:sldLayoutId xmlns:r="http://schemas.openxmlformats.org/officeDocument/2006/relationships" id="2147483649" r:id="R46d3cbe3a1cd4f9a"/>
-    <p:sldLayoutId xmlns:r="http://schemas.openxmlformats.org/officeDocument/2006/relationships" id="2147483650" r:id="R5788ee8f299f4e18"/>
+    <p:sldLayoutId xmlns:r="http://schemas.openxmlformats.org/officeDocument/2006/relationships" id="2147483649" r:id="R4cb1ee662fba415d"/>
+    <p:sldLayoutId xmlns:r="http://schemas.openxmlformats.org/officeDocument/2006/relationships" id="2147483650" r:id="Rc3b35c7ec9a04da2"/>
   </p:sldLayoutIdLst>
   <p:hf sldNum="0" hdr="0" ftr="0" dt="0"/>
   <p:txStyles>
@@ -1936,7 +1936,7 @@
           <p:nvPr/>
         </p:nvPicPr>
         <p:blipFill>
-          <a:blip xmlns:r="http://schemas.openxmlformats.org/officeDocument/2006/relationships" xmlns:a="http://schemas.openxmlformats.org/drawingml/2006/main" r:embed="Raecf304d9b914b56"/>
+          <a:blip xmlns:r="http://schemas.openxmlformats.org/officeDocument/2006/relationships" xmlns:a="http://schemas.openxmlformats.org/drawingml/2006/main" r:embed="Rf4603d1612de4ea2"/>
           <a:stretch xmlns:a="http://schemas.openxmlformats.org/drawingml/2006/main">
             <a:fillRect l="0" t="0" r="0" b="0"/>
           </a:stretch>
@@ -2445,7 +2445,7 @@
           <p:nvPr/>
         </p:nvPicPr>
         <p:blipFill>
-          <a:blip xmlns:r="http://schemas.openxmlformats.org/officeDocument/2006/relationships" xmlns:a="http://schemas.openxmlformats.org/drawingml/2006/main" r:embed="R8f142700679b46a8"/>
+          <a:blip xmlns:r="http://schemas.openxmlformats.org/officeDocument/2006/relationships" xmlns:a="http://schemas.openxmlformats.org/drawingml/2006/main" r:embed="R8c4294e134f04bc8"/>
           <a:stretch xmlns:a="http://schemas.openxmlformats.org/drawingml/2006/main"/>
         </p:blipFill>
         <p:spPr>
@@ -2858,7 +2858,7 @@
                 <a:ea typeface="Segoe UI"/>
                 <a:cs typeface="Segoe UI"/>
               </a:rPr>
-              <a:t>60 days</a:t>
+              <a:t>60 days + 200+ languages</a:t>
             </a:r>
             <a:endParaRPr sz="1080"/>
           </a:p>
@@ -3083,7 +3083,7 @@
                 <a:ea typeface="Segoe UI"/>
                 <a:cs typeface="Segoe UI"/>
               </a:rPr>
-              <a:t>Arabic, Hindi and Urdu</a:t>
+              <a:t>Expanded SOP coverage</a:t>
             </a:r>
             <a:endParaRPr sz="1080"/>
           </a:p>
@@ -4299,7 +4299,7 @@
           <p:nvPr/>
         </p:nvPicPr>
         <p:blipFill>
-          <a:blip xmlns:r="http://schemas.openxmlformats.org/officeDocument/2006/relationships" xmlns:a="http://schemas.openxmlformats.org/drawingml/2006/main" r:embed="R36791a9925b5454d"/>
+          <a:blip xmlns:r="http://schemas.openxmlformats.org/officeDocument/2006/relationships" xmlns:a="http://schemas.openxmlformats.org/drawingml/2006/main" r:embed="R13562ff834f043b0"/>
           <a:stretch xmlns:a="http://schemas.openxmlformats.org/drawingml/2006/main"/>
         </p:blipFill>
         <p:spPr>
@@ -5783,7 +5783,7 @@
           <p:nvPr/>
         </p:nvPicPr>
         <p:blipFill>
-          <a:blip xmlns:r="http://schemas.openxmlformats.org/officeDocument/2006/relationships" xmlns:a="http://schemas.openxmlformats.org/drawingml/2006/main" r:embed="R3f3ee030c13841e0"/>
+          <a:blip xmlns:r="http://schemas.openxmlformats.org/officeDocument/2006/relationships" xmlns:a="http://schemas.openxmlformats.org/drawingml/2006/main" r:embed="Rac3fc85983ba4d98"/>
           <a:stretch xmlns:a="http://schemas.openxmlformats.org/drawingml/2006/main"/>
         </p:blipFill>
         <p:spPr>
@@ -6986,7 +6986,7 @@
           <p:nvPr/>
         </p:nvPicPr>
         <p:blipFill>
-          <a:blip xmlns:r="http://schemas.openxmlformats.org/officeDocument/2006/relationships" xmlns:a="http://schemas.openxmlformats.org/drawingml/2006/main" r:embed="R0b3a4db8f69842f1"/>
+          <a:blip xmlns:r="http://schemas.openxmlformats.org/officeDocument/2006/relationships" xmlns:a="http://schemas.openxmlformats.org/drawingml/2006/main" r:embed="Re22298ad399444ab"/>
           <a:stretch xmlns:a="http://schemas.openxmlformats.org/drawingml/2006/main"/>
         </p:blipFill>
         <p:spPr>
@@ -8165,7 +8165,7 @@
           <p:nvPr/>
         </p:nvPicPr>
         <p:blipFill>
-          <a:blip xmlns:r="http://schemas.openxmlformats.org/officeDocument/2006/relationships" xmlns:a="http://schemas.openxmlformats.org/drawingml/2006/main" r:embed="R45a79daa31394991"/>
+          <a:blip xmlns:r="http://schemas.openxmlformats.org/officeDocument/2006/relationships" xmlns:a="http://schemas.openxmlformats.org/drawingml/2006/main" r:embed="R1ce63c5af1594df9"/>
           <a:stretch xmlns:a="http://schemas.openxmlformats.org/drawingml/2006/main"/>
         </p:blipFill>
         <p:spPr>
@@ -10752,7 +10752,7 @@
           <p:nvPr/>
         </p:nvPicPr>
         <p:blipFill>
-          <a:blip xmlns:r="http://schemas.openxmlformats.org/officeDocument/2006/relationships" xmlns:a="http://schemas.openxmlformats.org/drawingml/2006/main" r:embed="R22d92448600747e2"/>
+          <a:blip xmlns:r="http://schemas.openxmlformats.org/officeDocument/2006/relationships" xmlns:a="http://schemas.openxmlformats.org/drawingml/2006/main" r:embed="Ra3bcba89bf624608"/>
           <a:stretch xmlns:a="http://schemas.openxmlformats.org/drawingml/2006/main"/>
         </p:blipFill>
         <p:spPr>
@@ -11180,7 +11180,7 @@
                 <a:ea typeface="Segoe UI"/>
                 <a:cs typeface="Segoe UI"/>
               </a:rPr>
-              <a:t>Multilingual deployment for diverse crews</a:t>
+              <a:t>200+ languages available from the pilot</a:t>
             </a:r>
             <a:endParaRPr sz="1110"/>
           </a:p>
@@ -12777,7 +12777,7 @@
           <p:nvPr/>
         </p:nvPicPr>
         <p:blipFill>
-          <a:blip xmlns:r="http://schemas.openxmlformats.org/officeDocument/2006/relationships" xmlns:a="http://schemas.openxmlformats.org/drawingml/2006/main" r:embed="R3190ffbca4e44104"/>
+          <a:blip xmlns:r="http://schemas.openxmlformats.org/officeDocument/2006/relationships" xmlns:a="http://schemas.openxmlformats.org/drawingml/2006/main" r:embed="Rf36e410563e34e65"/>
           <a:stretch xmlns:a="http://schemas.openxmlformats.org/drawingml/2006/main"/>
         </p:blipFill>
         <p:spPr>
@@ -14980,7 +14980,7 @@
           <p:nvPr/>
         </p:nvPicPr>
         <p:blipFill>
-          <a:blip xmlns:r="http://schemas.openxmlformats.org/officeDocument/2006/relationships" xmlns:a="http://schemas.openxmlformats.org/drawingml/2006/main" r:embed="R86d70854df3e42f2"/>
+          <a:blip xmlns:r="http://schemas.openxmlformats.org/officeDocument/2006/relationships" xmlns:a="http://schemas.openxmlformats.org/drawingml/2006/main" r:embed="R415e71e37cac4d69"/>
           <a:stretch xmlns:a="http://schemas.openxmlformats.org/drawingml/2006/main"/>
         </p:blipFill>
         <p:spPr>
@@ -15419,7 +15419,7 @@
                 <a:ea typeface="Segoe UI"/>
                 <a:cs typeface="Segoe UI"/>
               </a:rPr>
-              <a:t>3 SOPs</a:t>
+              <a:t>3 SOPs + 200+ languages</a:t>
             </a:r>
             <a:endParaRPr sz="1070"/>
           </a:p>
@@ -16126,7 +16126,7 @@
                 <a:ea typeface="Segoe UI"/>
                 <a:cs typeface="Segoe UI"/>
               </a:rPr>
-              <a:t>Multilingual and custom rules</a:t>
+              <a:t>Advanced governance and custom rules</a:t>
             </a:r>
             <a:endParaRPr sz="1070"/>
           </a:p>
@@ -16412,7 +16412,7 @@
           <p:nvPr/>
         </p:nvPicPr>
         <p:blipFill>
-          <a:blip xmlns:r="http://schemas.openxmlformats.org/officeDocument/2006/relationships" xmlns:a="http://schemas.openxmlformats.org/drawingml/2006/main" r:embed="R742427750c6b4ec6"/>
+          <a:blip xmlns:r="http://schemas.openxmlformats.org/officeDocument/2006/relationships" xmlns:a="http://schemas.openxmlformats.org/drawingml/2006/main" r:embed="R91587caa285940db"/>
           <a:stretch xmlns:a="http://schemas.openxmlformats.org/drawingml/2006/main"/>
         </p:blipFill>
         <p:spPr>
@@ -18307,7 +18307,7 @@
           <p:nvPr/>
         </p:nvPicPr>
         <p:blipFill>
-          <a:blip xmlns:r="http://schemas.openxmlformats.org/officeDocument/2006/relationships" xmlns:a="http://schemas.openxmlformats.org/drawingml/2006/main" r:embed="R2e210221a89b4efd"/>
+          <a:blip xmlns:r="http://schemas.openxmlformats.org/officeDocument/2006/relationships" xmlns:a="http://schemas.openxmlformats.org/drawingml/2006/main" r:embed="R66985f15a6d04459"/>
           <a:stretch xmlns:a="http://schemas.openxmlformats.org/drawingml/2006/main"/>
         </p:blipFill>
         <p:spPr>

</xml_diff>

<commit_message>
Remove red warning outline
</commit_message>
<xml_diff>
--- a/docs/presentation/HeatSafe_Business_Model_Branded.pptx
+++ b/docs/presentation/HeatSafe_Business_Model_Branded.pptx
@@ -2,22 +2,22 @@
 <file path=ppt/presentation.xml><?xml version="1.0" encoding="utf-8"?>
 <p:presentation xmlns:p="http://schemas.openxmlformats.org/presentationml/2006/main">
   <p:sldMasterIdLst>
-    <p:sldMasterId xmlns:r="http://schemas.openxmlformats.org/officeDocument/2006/relationships" id="2147483648" r:id="R66889a80247745a4"/>
+    <p:sldMasterId xmlns:r="http://schemas.openxmlformats.org/officeDocument/2006/relationships" id="2147483648" r:id="Ra2871fdc86e54c6d"/>
   </p:sldMasterIdLst>
   <p:notesMasterIdLst>
-    <p:notesMasterId xmlns:r="http://schemas.openxmlformats.org/officeDocument/2006/relationships" r:id="Rc3d4264c9c1a4293"/>
+    <p:notesMasterId xmlns:r="http://schemas.openxmlformats.org/officeDocument/2006/relationships" r:id="R0a9366ecab1f43e8"/>
   </p:notesMasterIdLst>
   <p:sldIdLst>
-    <p:sldId xmlns:r="http://schemas.openxmlformats.org/officeDocument/2006/relationships" id="256" r:id="Rd6aa0bdde66e4ac3"/>
-    <p:sldId xmlns:r="http://schemas.openxmlformats.org/officeDocument/2006/relationships" id="257" r:id="Rd65bad9fff4c4917"/>
-    <p:sldId xmlns:r="http://schemas.openxmlformats.org/officeDocument/2006/relationships" id="258" r:id="R3b6685afbea14e88"/>
-    <p:sldId xmlns:r="http://schemas.openxmlformats.org/officeDocument/2006/relationships" id="259" r:id="R7c0e12640f3241c9"/>
-    <p:sldId xmlns:r="http://schemas.openxmlformats.org/officeDocument/2006/relationships" id="260" r:id="R6ef5927595d1420b"/>
-    <p:sldId xmlns:r="http://schemas.openxmlformats.org/officeDocument/2006/relationships" id="261" r:id="R1cfda52715e34012"/>
-    <p:sldId xmlns:r="http://schemas.openxmlformats.org/officeDocument/2006/relationships" id="262" r:id="Rfb20379ab5fe46a3"/>
-    <p:sldId xmlns:r="http://schemas.openxmlformats.org/officeDocument/2006/relationships" id="263" r:id="Ree0cf4e562374661"/>
-    <p:sldId xmlns:r="http://schemas.openxmlformats.org/officeDocument/2006/relationships" id="264" r:id="R52a8106e4a50488b"/>
-    <p:sldId xmlns:r="http://schemas.openxmlformats.org/officeDocument/2006/relationships" id="265" r:id="Ra08ba1c8b57a462a"/>
+    <p:sldId xmlns:r="http://schemas.openxmlformats.org/officeDocument/2006/relationships" id="256" r:id="Rcd94ccb1d9264b36"/>
+    <p:sldId xmlns:r="http://schemas.openxmlformats.org/officeDocument/2006/relationships" id="257" r:id="R09eb7e7696ce4963"/>
+    <p:sldId xmlns:r="http://schemas.openxmlformats.org/officeDocument/2006/relationships" id="258" r:id="R0fa959232f754411"/>
+    <p:sldId xmlns:r="http://schemas.openxmlformats.org/officeDocument/2006/relationships" id="259" r:id="R4163d2149cef45f4"/>
+    <p:sldId xmlns:r="http://schemas.openxmlformats.org/officeDocument/2006/relationships" id="260" r:id="R3fe682bdae774371"/>
+    <p:sldId xmlns:r="http://schemas.openxmlformats.org/officeDocument/2006/relationships" id="261" r:id="R11a82ce82f4e4e5a"/>
+    <p:sldId xmlns:r="http://schemas.openxmlformats.org/officeDocument/2006/relationships" id="262" r:id="R19eb9b73dc864235"/>
+    <p:sldId xmlns:r="http://schemas.openxmlformats.org/officeDocument/2006/relationships" id="263" r:id="R52404f6fd98f41c8"/>
+    <p:sldId xmlns:r="http://schemas.openxmlformats.org/officeDocument/2006/relationships" id="264" r:id="R36df8f89223d4c56"/>
+    <p:sldId xmlns:r="http://schemas.openxmlformats.org/officeDocument/2006/relationships" id="265" r:id="R41dd8d2caaa049a1"/>
   </p:sldIdLst>
   <p:sldSz cx="12192000" cy="6858000"/>
   <p:notesSz cx="6858000" cy="9144000"/>
@@ -1360,8 +1360,8 @@
   </p:cSld>
   <p:clrMap bg1="lt1" tx1="dk1" bg2="lt2" tx2="dk2" accent1="accent1" accent2="accent2" accent3="accent3" accent4="accent4" accent5="accent5" accent6="accent6" hlink="hlink" folHlink="folHlink"/>
   <p:sldLayoutIdLst>
-    <p:sldLayoutId xmlns:r="http://schemas.openxmlformats.org/officeDocument/2006/relationships" id="2147483649" r:id="R4cb1ee662fba415d"/>
-    <p:sldLayoutId xmlns:r="http://schemas.openxmlformats.org/officeDocument/2006/relationships" id="2147483650" r:id="Rc3b35c7ec9a04da2"/>
+    <p:sldLayoutId xmlns:r="http://schemas.openxmlformats.org/officeDocument/2006/relationships" id="2147483649" r:id="R4ae96e15b4b741ec"/>
+    <p:sldLayoutId xmlns:r="http://schemas.openxmlformats.org/officeDocument/2006/relationships" id="2147483650" r:id="R2ee304a909554b85"/>
   </p:sldLayoutIdLst>
   <p:hf sldNum="0" hdr="0" ftr="0" dt="0"/>
   <p:txStyles>
@@ -1936,7 +1936,7 @@
           <p:nvPr/>
         </p:nvPicPr>
         <p:blipFill>
-          <a:blip xmlns:r="http://schemas.openxmlformats.org/officeDocument/2006/relationships" xmlns:a="http://schemas.openxmlformats.org/drawingml/2006/main" r:embed="Rf4603d1612de4ea2"/>
+          <a:blip xmlns:r="http://schemas.openxmlformats.org/officeDocument/2006/relationships" xmlns:a="http://schemas.openxmlformats.org/drawingml/2006/main" r:embed="Rcb540170f2894eec"/>
           <a:stretch xmlns:a="http://schemas.openxmlformats.org/drawingml/2006/main">
             <a:fillRect l="0" t="0" r="0" b="0"/>
           </a:stretch>
@@ -2445,7 +2445,7 @@
           <p:nvPr/>
         </p:nvPicPr>
         <p:blipFill>
-          <a:blip xmlns:r="http://schemas.openxmlformats.org/officeDocument/2006/relationships" xmlns:a="http://schemas.openxmlformats.org/drawingml/2006/main" r:embed="R8c4294e134f04bc8"/>
+          <a:blip xmlns:r="http://schemas.openxmlformats.org/officeDocument/2006/relationships" xmlns:a="http://schemas.openxmlformats.org/drawingml/2006/main" r:embed="Rfa6b3f1e5cf84599"/>
           <a:stretch xmlns:a="http://schemas.openxmlformats.org/drawingml/2006/main"/>
         </p:blipFill>
         <p:spPr>
@@ -4299,7 +4299,7 @@
           <p:nvPr/>
         </p:nvPicPr>
         <p:blipFill>
-          <a:blip xmlns:r="http://schemas.openxmlformats.org/officeDocument/2006/relationships" xmlns:a="http://schemas.openxmlformats.org/drawingml/2006/main" r:embed="R13562ff834f043b0"/>
+          <a:blip xmlns:r="http://schemas.openxmlformats.org/officeDocument/2006/relationships" xmlns:a="http://schemas.openxmlformats.org/drawingml/2006/main" r:embed="R7d2913dfc2574323"/>
           <a:stretch xmlns:a="http://schemas.openxmlformats.org/drawingml/2006/main"/>
         </p:blipFill>
         <p:spPr>
@@ -5783,7 +5783,7 @@
           <p:nvPr/>
         </p:nvPicPr>
         <p:blipFill>
-          <a:blip xmlns:r="http://schemas.openxmlformats.org/officeDocument/2006/relationships" xmlns:a="http://schemas.openxmlformats.org/drawingml/2006/main" r:embed="Rac3fc85983ba4d98"/>
+          <a:blip xmlns:r="http://schemas.openxmlformats.org/officeDocument/2006/relationships" xmlns:a="http://schemas.openxmlformats.org/drawingml/2006/main" r:embed="R1ddccd83ba284b9c"/>
           <a:stretch xmlns:a="http://schemas.openxmlformats.org/drawingml/2006/main"/>
         </p:blipFill>
         <p:spPr>
@@ -6986,7 +6986,7 @@
           <p:nvPr/>
         </p:nvPicPr>
         <p:blipFill>
-          <a:blip xmlns:r="http://schemas.openxmlformats.org/officeDocument/2006/relationships" xmlns:a="http://schemas.openxmlformats.org/drawingml/2006/main" r:embed="Re22298ad399444ab"/>
+          <a:blip xmlns:r="http://schemas.openxmlformats.org/officeDocument/2006/relationships" xmlns:a="http://schemas.openxmlformats.org/drawingml/2006/main" r:embed="R139e92a6dbfe48e7"/>
           <a:stretch xmlns:a="http://schemas.openxmlformats.org/drawingml/2006/main"/>
         </p:blipFill>
         <p:spPr>
@@ -8165,7 +8165,7 @@
           <p:nvPr/>
         </p:nvPicPr>
         <p:blipFill>
-          <a:blip xmlns:r="http://schemas.openxmlformats.org/officeDocument/2006/relationships" xmlns:a="http://schemas.openxmlformats.org/drawingml/2006/main" r:embed="R1ce63c5af1594df9"/>
+          <a:blip xmlns:r="http://schemas.openxmlformats.org/officeDocument/2006/relationships" xmlns:a="http://schemas.openxmlformats.org/drawingml/2006/main" r:embed="R9b6db6be17174f69"/>
           <a:stretch xmlns:a="http://schemas.openxmlformats.org/drawingml/2006/main"/>
         </p:blipFill>
         <p:spPr>
@@ -10591,10 +10591,8 @@
           <a:solidFill xmlns:a="http://schemas.openxmlformats.org/drawingml/2006/main">
             <a:srgbClr val="FDEEEE"/>
           </a:solidFill>
-          <a:ln xmlns:a="http://schemas.openxmlformats.org/drawingml/2006/main" w="12700">
-            <a:solidFill>
-              <a:srgbClr val="EF4444"/>
-            </a:solidFill>
+          <a:ln xmlns:a="http://schemas.openxmlformats.org/drawingml/2006/main" w="0">
+            <a:noFill/>
             <a:prstDash val="solid"/>
           </a:ln>
         </p:spPr>
@@ -10752,7 +10750,7 @@
           <p:nvPr/>
         </p:nvPicPr>
         <p:blipFill>
-          <a:blip xmlns:r="http://schemas.openxmlformats.org/officeDocument/2006/relationships" xmlns:a="http://schemas.openxmlformats.org/drawingml/2006/main" r:embed="Ra3bcba89bf624608"/>
+          <a:blip xmlns:r="http://schemas.openxmlformats.org/officeDocument/2006/relationships" xmlns:a="http://schemas.openxmlformats.org/drawingml/2006/main" r:embed="R3287bffe9cbd4b4a"/>
           <a:stretch xmlns:a="http://schemas.openxmlformats.org/drawingml/2006/main"/>
         </p:blipFill>
         <p:spPr>
@@ -12777,7 +12775,7 @@
           <p:nvPr/>
         </p:nvPicPr>
         <p:blipFill>
-          <a:blip xmlns:r="http://schemas.openxmlformats.org/officeDocument/2006/relationships" xmlns:a="http://schemas.openxmlformats.org/drawingml/2006/main" r:embed="Rf36e410563e34e65"/>
+          <a:blip xmlns:r="http://schemas.openxmlformats.org/officeDocument/2006/relationships" xmlns:a="http://schemas.openxmlformats.org/drawingml/2006/main" r:embed="R84b64d956a2c4f17"/>
           <a:stretch xmlns:a="http://schemas.openxmlformats.org/drawingml/2006/main"/>
         </p:blipFill>
         <p:spPr>
@@ -14980,7 +14978,7 @@
           <p:nvPr/>
         </p:nvPicPr>
         <p:blipFill>
-          <a:blip xmlns:r="http://schemas.openxmlformats.org/officeDocument/2006/relationships" xmlns:a="http://schemas.openxmlformats.org/drawingml/2006/main" r:embed="R415e71e37cac4d69"/>
+          <a:blip xmlns:r="http://schemas.openxmlformats.org/officeDocument/2006/relationships" xmlns:a="http://schemas.openxmlformats.org/drawingml/2006/main" r:embed="R27b04d14bd1e4cd4"/>
           <a:stretch xmlns:a="http://schemas.openxmlformats.org/drawingml/2006/main"/>
         </p:blipFill>
         <p:spPr>
@@ -16412,7 +16410,7 @@
           <p:nvPr/>
         </p:nvPicPr>
         <p:blipFill>
-          <a:blip xmlns:r="http://schemas.openxmlformats.org/officeDocument/2006/relationships" xmlns:a="http://schemas.openxmlformats.org/drawingml/2006/main" r:embed="R91587caa285940db"/>
+          <a:blip xmlns:r="http://schemas.openxmlformats.org/officeDocument/2006/relationships" xmlns:a="http://schemas.openxmlformats.org/drawingml/2006/main" r:embed="R735f2572f5de4a9c"/>
           <a:stretch xmlns:a="http://schemas.openxmlformats.org/drawingml/2006/main"/>
         </p:blipFill>
         <p:spPr>
@@ -18307,7 +18305,7 @@
           <p:nvPr/>
         </p:nvPicPr>
         <p:blipFill>
-          <a:blip xmlns:r="http://schemas.openxmlformats.org/officeDocument/2006/relationships" xmlns:a="http://schemas.openxmlformats.org/drawingml/2006/main" r:embed="R66985f15a6d04459"/>
+          <a:blip xmlns:r="http://schemas.openxmlformats.org/officeDocument/2006/relationships" xmlns:a="http://schemas.openxmlformats.org/drawingml/2006/main" r:embed="Red94755bd23645fa"/>
           <a:stretch xmlns:a="http://schemas.openxmlformats.org/drawingml/2006/main"/>
         </p:blipFill>
         <p:spPr>

</xml_diff>

<commit_message>
Remove oversized demo information icon
</commit_message>
<xml_diff>
--- a/docs/presentation/HeatSafe_Business_Model_Branded.pptx
+++ b/docs/presentation/HeatSafe_Business_Model_Branded.pptx
@@ -2,23 +2,23 @@
 <file path=ppt/presentation.xml><?xml version="1.0" encoding="utf-8"?>
 <p:presentation xmlns:p="http://schemas.openxmlformats.org/presentationml/2006/main">
   <p:sldMasterIdLst>
-    <p:sldMasterId xmlns:r="http://schemas.openxmlformats.org/officeDocument/2006/relationships" id="2147483648" r:id="Rdcba41d50787414e"/>
+    <p:sldMasterId xmlns:r="http://schemas.openxmlformats.org/officeDocument/2006/relationships" id="2147483648" r:id="R0e1cc3e41a2841f7"/>
   </p:sldMasterIdLst>
   <p:notesMasterIdLst>
-    <p:notesMasterId xmlns:r="http://schemas.openxmlformats.org/officeDocument/2006/relationships" r:id="Rbc41082804114c23"/>
+    <p:notesMasterId xmlns:r="http://schemas.openxmlformats.org/officeDocument/2006/relationships" r:id="R8e44e8b83ca244b0"/>
   </p:notesMasterIdLst>
   <p:sldIdLst>
-    <p:sldId xmlns:r="http://schemas.openxmlformats.org/officeDocument/2006/relationships" id="256" r:id="R83b8082411cd4150"/>
-    <p:sldId xmlns:r="http://schemas.openxmlformats.org/officeDocument/2006/relationships" id="257" r:id="R3bf67337a15f4284"/>
-    <p:sldId xmlns:r="http://schemas.openxmlformats.org/officeDocument/2006/relationships" id="258" r:id="Rb6429202b687400b"/>
-    <p:sldId xmlns:r="http://schemas.openxmlformats.org/officeDocument/2006/relationships" id="259" r:id="Rc67d9d5d10be4ba9"/>
-    <p:sldId xmlns:r="http://schemas.openxmlformats.org/officeDocument/2006/relationships" id="260" r:id="Rad1d9eeca44749f0"/>
-    <p:sldId xmlns:r="http://schemas.openxmlformats.org/officeDocument/2006/relationships" id="261" r:id="Rf9f5905d12df4698"/>
-    <p:sldId xmlns:r="http://schemas.openxmlformats.org/officeDocument/2006/relationships" id="262" r:id="Ra7e10545cb8b4ab1"/>
-    <p:sldId xmlns:r="http://schemas.openxmlformats.org/officeDocument/2006/relationships" id="263" r:id="R6714fe6f254a4f6e"/>
-    <p:sldId xmlns:r="http://schemas.openxmlformats.org/officeDocument/2006/relationships" id="264" r:id="R4f7209586c174625"/>
-    <p:sldId xmlns:r="http://schemas.openxmlformats.org/officeDocument/2006/relationships" id="265" r:id="R2ec8c8e5bcb04f31"/>
-    <p:sldId xmlns:r="http://schemas.openxmlformats.org/officeDocument/2006/relationships" id="266" r:id="Rf8aa84f9b1254a49"/>
+    <p:sldId xmlns:r="http://schemas.openxmlformats.org/officeDocument/2006/relationships" id="256" r:id="R719d54c6866141c3"/>
+    <p:sldId xmlns:r="http://schemas.openxmlformats.org/officeDocument/2006/relationships" id="257" r:id="Rbb82b2ee085b40dd"/>
+    <p:sldId xmlns:r="http://schemas.openxmlformats.org/officeDocument/2006/relationships" id="258" r:id="Rffedaf1897c84f6f"/>
+    <p:sldId xmlns:r="http://schemas.openxmlformats.org/officeDocument/2006/relationships" id="259" r:id="Rcb37fe0cb017440d"/>
+    <p:sldId xmlns:r="http://schemas.openxmlformats.org/officeDocument/2006/relationships" id="260" r:id="R99eaa94818b64dd3"/>
+    <p:sldId xmlns:r="http://schemas.openxmlformats.org/officeDocument/2006/relationships" id="261" r:id="R42ed0fb167984064"/>
+    <p:sldId xmlns:r="http://schemas.openxmlformats.org/officeDocument/2006/relationships" id="262" r:id="R5dac546906744804"/>
+    <p:sldId xmlns:r="http://schemas.openxmlformats.org/officeDocument/2006/relationships" id="263" r:id="R5047864856364956"/>
+    <p:sldId xmlns:r="http://schemas.openxmlformats.org/officeDocument/2006/relationships" id="264" r:id="R8be979b88c99401a"/>
+    <p:sldId xmlns:r="http://schemas.openxmlformats.org/officeDocument/2006/relationships" id="265" r:id="R0ed93765464045d7"/>
+    <p:sldId xmlns:r="http://schemas.openxmlformats.org/officeDocument/2006/relationships" id="266" r:id="R9d8ec12aac57433d"/>
   </p:sldIdLst>
   <p:sldSz cx="12192000" cy="6858000"/>
   <p:notesSz cx="6858000" cy="9144000"/>
@@ -1432,8 +1432,8 @@
   </p:cSld>
   <p:clrMap bg1="lt1" tx1="dk1" bg2="lt2" tx2="dk2" accent1="accent1" accent2="accent2" accent3="accent3" accent4="accent4" accent5="accent5" accent6="accent6" hlink="hlink" folHlink="folHlink"/>
   <p:sldLayoutIdLst>
-    <p:sldLayoutId xmlns:r="http://schemas.openxmlformats.org/officeDocument/2006/relationships" id="2147483649" r:id="Rfd8f5840837342df"/>
-    <p:sldLayoutId xmlns:r="http://schemas.openxmlformats.org/officeDocument/2006/relationships" id="2147483650" r:id="R32d60c918b3e409f"/>
+    <p:sldLayoutId xmlns:r="http://schemas.openxmlformats.org/officeDocument/2006/relationships" id="2147483649" r:id="R01f2a62e01c644ff"/>
+    <p:sldLayoutId xmlns:r="http://schemas.openxmlformats.org/officeDocument/2006/relationships" id="2147483650" r:id="R12aceb6f5ca741e1"/>
   </p:sldLayoutIdLst>
   <p:hf sldNum="0" hdr="0" ftr="0" dt="0"/>
   <p:txStyles>
@@ -2008,7 +2008,7 @@
           <p:nvPr/>
         </p:nvPicPr>
         <p:blipFill>
-          <a:blip xmlns:r="http://schemas.openxmlformats.org/officeDocument/2006/relationships" xmlns:a="http://schemas.openxmlformats.org/drawingml/2006/main" r:embed="Re8b4fc879e894f4d"/>
+          <a:blip xmlns:r="http://schemas.openxmlformats.org/officeDocument/2006/relationships" xmlns:a="http://schemas.openxmlformats.org/drawingml/2006/main" r:embed="R2408e2b2e6d244a7"/>
           <a:stretch xmlns:a="http://schemas.openxmlformats.org/drawingml/2006/main">
             <a:fillRect l="0" t="0" r="0" b="0"/>
           </a:stretch>
@@ -2517,7 +2517,7 @@
           <p:nvPr/>
         </p:nvPicPr>
         <p:blipFill>
-          <a:blip xmlns:r="http://schemas.openxmlformats.org/officeDocument/2006/relationships" xmlns:a="http://schemas.openxmlformats.org/drawingml/2006/main" r:embed="Rf3cf75bc1e244863"/>
+          <a:blip xmlns:r="http://schemas.openxmlformats.org/officeDocument/2006/relationships" xmlns:a="http://schemas.openxmlformats.org/drawingml/2006/main" r:embed="R4c69c7d38b534b9c"/>
           <a:stretch xmlns:a="http://schemas.openxmlformats.org/drawingml/2006/main"/>
         </p:blipFill>
         <p:spPr>
@@ -4412,7 +4412,7 @@
           <p:nvPr/>
         </p:nvPicPr>
         <p:blipFill>
-          <a:blip xmlns:r="http://schemas.openxmlformats.org/officeDocument/2006/relationships" xmlns:a="http://schemas.openxmlformats.org/drawingml/2006/main" r:embed="Rf5ca6055253c4c20"/>
+          <a:blip xmlns:r="http://schemas.openxmlformats.org/officeDocument/2006/relationships" xmlns:a="http://schemas.openxmlformats.org/drawingml/2006/main" r:embed="Rbf60002f31f44018"/>
           <a:stretch xmlns:a="http://schemas.openxmlformats.org/drawingml/2006/main"/>
         </p:blipFill>
         <p:spPr>
@@ -6266,7 +6266,7 @@
           <p:nvPr/>
         </p:nvPicPr>
         <p:blipFill>
-          <a:blip xmlns:r="http://schemas.openxmlformats.org/officeDocument/2006/relationships" xmlns:a="http://schemas.openxmlformats.org/drawingml/2006/main" r:embed="R34ab7c0f6f3a419c"/>
+          <a:blip xmlns:r="http://schemas.openxmlformats.org/officeDocument/2006/relationships" xmlns:a="http://schemas.openxmlformats.org/drawingml/2006/main" r:embed="R49d180984c234359"/>
           <a:stretch xmlns:a="http://schemas.openxmlformats.org/drawingml/2006/main"/>
         </p:blipFill>
         <p:spPr>
@@ -7750,7 +7750,7 @@
           <p:nvPr/>
         </p:nvPicPr>
         <p:blipFill>
-          <a:blip xmlns:r="http://schemas.openxmlformats.org/officeDocument/2006/relationships" xmlns:a="http://schemas.openxmlformats.org/drawingml/2006/main" r:embed="Re302e1284067424e"/>
+          <a:blip xmlns:r="http://schemas.openxmlformats.org/officeDocument/2006/relationships" xmlns:a="http://schemas.openxmlformats.org/drawingml/2006/main" r:embed="R5852414c836a49f3"/>
           <a:stretch xmlns:a="http://schemas.openxmlformats.org/drawingml/2006/main"/>
         </p:blipFill>
         <p:spPr>
@@ -8953,7 +8953,7 @@
           <p:nvPr/>
         </p:nvPicPr>
         <p:blipFill>
-          <a:blip xmlns:r="http://schemas.openxmlformats.org/officeDocument/2006/relationships" xmlns:a="http://schemas.openxmlformats.org/drawingml/2006/main" r:embed="R5663be01ca744ee0"/>
+          <a:blip xmlns:r="http://schemas.openxmlformats.org/officeDocument/2006/relationships" xmlns:a="http://schemas.openxmlformats.org/drawingml/2006/main" r:embed="Rd42ed7b575724854"/>
           <a:stretch xmlns:a="http://schemas.openxmlformats.org/drawingml/2006/main"/>
         </p:blipFill>
         <p:spPr>
@@ -10132,7 +10132,7 @@
           <p:nvPr/>
         </p:nvPicPr>
         <p:blipFill>
-          <a:blip xmlns:r="http://schemas.openxmlformats.org/officeDocument/2006/relationships" xmlns:a="http://schemas.openxmlformats.org/drawingml/2006/main" r:embed="Ra64dde5f1e074913"/>
+          <a:blip xmlns:r="http://schemas.openxmlformats.org/officeDocument/2006/relationships" xmlns:a="http://schemas.openxmlformats.org/drawingml/2006/main" r:embed="R2456f2d3022341d0"/>
           <a:stretch xmlns:a="http://schemas.openxmlformats.org/drawingml/2006/main"/>
         </p:blipFill>
         <p:spPr>
@@ -12717,7 +12717,7 @@
           <p:nvPr/>
         </p:nvPicPr>
         <p:blipFill>
-          <a:blip xmlns:r="http://schemas.openxmlformats.org/officeDocument/2006/relationships" xmlns:a="http://schemas.openxmlformats.org/drawingml/2006/main" r:embed="R111dff647461455e"/>
+          <a:blip xmlns:r="http://schemas.openxmlformats.org/officeDocument/2006/relationships" xmlns:a="http://schemas.openxmlformats.org/drawingml/2006/main" r:embed="Ra4f99cf92c254ab3"/>
           <a:stretch xmlns:a="http://schemas.openxmlformats.org/drawingml/2006/main"/>
         </p:blipFill>
         <p:spPr>
@@ -14742,7 +14742,7 @@
           <p:nvPr/>
         </p:nvPicPr>
         <p:blipFill>
-          <a:blip xmlns:r="http://schemas.openxmlformats.org/officeDocument/2006/relationships" xmlns:a="http://schemas.openxmlformats.org/drawingml/2006/main" r:embed="Ra5f418e0d7824918"/>
+          <a:blip xmlns:r="http://schemas.openxmlformats.org/officeDocument/2006/relationships" xmlns:a="http://schemas.openxmlformats.org/drawingml/2006/main" r:embed="R1e8fa77d18094964"/>
           <a:stretch xmlns:a="http://schemas.openxmlformats.org/drawingml/2006/main"/>
         </p:blipFill>
         <p:spPr>
@@ -14845,7 +14845,7 @@
           <p:nvPr/>
         </p:nvPicPr>
         <p:blipFill>
-          <a:blip xmlns:r="http://schemas.openxmlformats.org/officeDocument/2006/relationships" xmlns:a="http://schemas.openxmlformats.org/drawingml/2006/main" r:embed="R531c5bb7e7ac46f9"/>
+          <a:blip xmlns:r="http://schemas.openxmlformats.org/officeDocument/2006/relationships" xmlns:a="http://schemas.openxmlformats.org/drawingml/2006/main" r:embed="Reed667eb4ded423f"/>
           <a:stretch xmlns:a="http://schemas.openxmlformats.org/drawingml/2006/main"/>
         </p:blipFill>
         <p:spPr>
@@ -15772,22 +15772,445 @@
       </p:sp>
       <p:sp>
         <p:nvSpPr>
-          <p:cNvPr id="27" name="Shape 25">
-            <a:extLst xmlns:a="http://schemas.openxmlformats.org/drawingml/2006/main">
-              <a:ext uri="{FF2B5EF4-FFF2-40B4-BE49-F238E27FC236}">
-                <a16:creationId xmlns:a16="http://schemas.microsoft.com/office/drawing/2014/main" id="{A35F330F-2173-474C-8340-000239A9356B}"/>
-              </a:ext>
-            </a:extLst>
-          </p:cNvPr>
-          <p:cNvSpPr>
-            <a:spLocks xmlns:a="http://schemas.openxmlformats.org/drawingml/2006/main" noGrp="1"/>
-          </p:cNvSpPr>
-          <p:nvPr/>
-        </p:nvSpPr>
-        <p:spPr>
-          <a:xfrm xmlns:a="http://schemas.openxmlformats.org/drawingml/2006/main">
-            <a:off x="5230368" y="5321808"/>
-            <a:ext cx="1097280" cy="1097280"/>
+          <p:cNvPr id="30" name="Shape 28">
+            <a:extLst xmlns:a="http://schemas.openxmlformats.org/drawingml/2006/main">
+              <a:ext uri="{FF2B5EF4-FFF2-40B4-BE49-F238E27FC236}">
+                <a16:creationId xmlns:a16="http://schemas.microsoft.com/office/drawing/2014/main" id="{F6637B3F-BF2C-45D2-85BE-80022973B1FC}"/>
+              </a:ext>
+            </a:extLst>
+          </p:cNvPr>
+          <p:cNvSpPr>
+            <a:spLocks xmlns:a="http://schemas.openxmlformats.org/drawingml/2006/main" noGrp="1"/>
+          </p:cNvSpPr>
+          <p:nvPr/>
+        </p:nvSpPr>
+        <p:spPr>
+          <a:xfrm xmlns:a="http://schemas.openxmlformats.org/drawingml/2006/main">
+            <a:off x="8165592" y="1901952"/>
+            <a:ext cx="3520440" cy="4306824"/>
+          </a:xfrm>
+          <a:prstGeom xmlns:a="http://schemas.openxmlformats.org/drawingml/2006/main" prst="roundRect">
+            <a:avLst>
+              <a:gd name="adj" fmla="val 3117"/>
+            </a:avLst>
+          </a:prstGeom>
+          <a:solidFill xmlns:a="http://schemas.openxmlformats.org/drawingml/2006/main">
+            <a:srgbClr val="F7F9FB"/>
+          </a:solidFill>
+          <a:ln xmlns:a="http://schemas.openxmlformats.org/drawingml/2006/main" w="10160">
+            <a:solidFill>
+              <a:srgbClr val="E1E4EA"/>
+            </a:solidFill>
+            <a:prstDash val="solid"/>
+          </a:ln>
+        </p:spPr>
+      </p:sp>
+      <p:sp>
+        <p:nvSpPr>
+          <p:cNvPr id="31" name="Text 29">
+            <a:extLst xmlns:a="http://schemas.openxmlformats.org/drawingml/2006/main">
+              <a:ext uri="{FF2B5EF4-FFF2-40B4-BE49-F238E27FC236}">
+                <a16:creationId xmlns:a16="http://schemas.microsoft.com/office/drawing/2014/main" id="{E9415021-1129-4F33-9689-D7381BE777ED}"/>
+              </a:ext>
+            </a:extLst>
+          </p:cNvPr>
+          <p:cNvSpPr>
+            <a:spLocks xmlns:a="http://schemas.openxmlformats.org/drawingml/2006/main" noGrp="1"/>
+          </p:cNvSpPr>
+          <p:nvPr/>
+        </p:nvSpPr>
+        <p:spPr>
+          <a:xfrm xmlns:a="http://schemas.openxmlformats.org/drawingml/2006/main">
+            <a:off x="8458200" y="2157984"/>
+            <a:ext cx="2926080" cy="219456"/>
+          </a:xfrm>
+          <a:prstGeom xmlns:a="http://schemas.openxmlformats.org/drawingml/2006/main" prst="rect">
+            <a:avLst/>
+          </a:prstGeom>
+          <a:noFill xmlns:a="http://schemas.openxmlformats.org/drawingml/2006/main"/>
+        </p:spPr>
+        <p:txBody>
+          <a:bodyPr xmlns:a="http://schemas.openxmlformats.org/drawingml/2006/main" wrap="square" lIns="0" tIns="0" rIns="0" bIns="0" anchor="ctr"/>
+          <a:lstStyle xmlns:a="http://schemas.openxmlformats.org/drawingml/2006/main"/>
+          <a:p xmlns:a="http://schemas.openxmlformats.org/drawingml/2006/main">
+            <a:pPr marL="0" indent="0" algn="ctr">
+              <a:buNone/>
+            </a:pPr>
+            <a:r>
+              <a:rPr sz="950" b="1">
+                <a:solidFill>
+                  <a:srgbClr val="6B7280"/>
+                </a:solidFill>
+                <a:latin typeface="Segoe UI"/>
+                <a:ea typeface="Segoe UI"/>
+                <a:cs typeface="Segoe UI"/>
+              </a:rPr>
+              <a:t>WHAT THE DEMO PROVES</a:t>
+            </a:r>
+            <a:endParaRPr sz="950"/>
+          </a:p>
+        </p:txBody>
+      </p:sp>
+      <p:sp>
+        <p:nvSpPr>
+          <p:cNvPr id="32" name="Shape 30">
+            <a:extLst xmlns:a="http://schemas.openxmlformats.org/drawingml/2006/main">
+              <a:ext uri="{FF2B5EF4-FFF2-40B4-BE49-F238E27FC236}">
+                <a16:creationId xmlns:a16="http://schemas.microsoft.com/office/drawing/2014/main" id="{F6F8662F-E3F9-42AE-BC45-951FD79F33F0}"/>
+              </a:ext>
+            </a:extLst>
+          </p:cNvPr>
+          <p:cNvSpPr>
+            <a:spLocks xmlns:a="http://schemas.openxmlformats.org/drawingml/2006/main" noGrp="1"/>
+          </p:cNvSpPr>
+          <p:nvPr/>
+        </p:nvSpPr>
+        <p:spPr>
+          <a:xfrm xmlns:a="http://schemas.openxmlformats.org/drawingml/2006/main">
+            <a:off x="8449056" y="2578608"/>
+            <a:ext cx="347472" cy="347472"/>
+          </a:xfrm>
+          <a:prstGeom xmlns:a="http://schemas.openxmlformats.org/drawingml/2006/main" prst="ellipse">
+            <a:avLst/>
+          </a:prstGeom>
+          <a:solidFill xmlns:a="http://schemas.openxmlformats.org/drawingml/2006/main">
+            <a:srgbClr val="3B82F6"/>
+          </a:solidFill>
+          <a:ln xmlns:a="http://schemas.openxmlformats.org/drawingml/2006/main" w="12700">
+            <a:solidFill>
+              <a:srgbClr val="3B82F6"/>
+            </a:solidFill>
+            <a:prstDash val="solid"/>
+          </a:ln>
+        </p:spPr>
+      </p:sp>
+      <p:sp>
+        <p:nvSpPr>
+          <p:cNvPr id="33" name="Text 31">
+            <a:extLst xmlns:a="http://schemas.openxmlformats.org/drawingml/2006/main">
+              <a:ext uri="{FF2B5EF4-FFF2-40B4-BE49-F238E27FC236}">
+                <a16:creationId xmlns:a16="http://schemas.microsoft.com/office/drawing/2014/main" id="{0980BE50-77E9-4901-B894-5DC224E3B570}"/>
+              </a:ext>
+            </a:extLst>
+          </p:cNvPr>
+          <p:cNvSpPr>
+            <a:spLocks xmlns:a="http://schemas.openxmlformats.org/drawingml/2006/main" noGrp="1"/>
+          </p:cNvSpPr>
+          <p:nvPr/>
+        </p:nvSpPr>
+        <p:spPr>
+          <a:xfrm xmlns:a="http://schemas.openxmlformats.org/drawingml/2006/main">
+            <a:off x="8449056" y="2628900"/>
+            <a:ext cx="347472" cy="292608"/>
+          </a:xfrm>
+          <a:prstGeom xmlns:a="http://schemas.openxmlformats.org/drawingml/2006/main" prst="rect">
+            <a:avLst/>
+          </a:prstGeom>
+          <a:noFill xmlns:a="http://schemas.openxmlformats.org/drawingml/2006/main"/>
+        </p:spPr>
+        <p:txBody>
+          <a:bodyPr xmlns:a="http://schemas.openxmlformats.org/drawingml/2006/main" wrap="square" lIns="0" tIns="0" rIns="0" bIns="0" anchor="ctr"/>
+          <a:lstStyle xmlns:a="http://schemas.openxmlformats.org/drawingml/2006/main"/>
+          <a:p xmlns:a="http://schemas.openxmlformats.org/drawingml/2006/main">
+            <a:pPr marL="0" indent="0" algn="ctr">
+              <a:buNone/>
+            </a:pPr>
+            <a:r>
+              <a:rPr sz="1400" b="1">
+                <a:solidFill>
+                  <a:srgbClr val="1C1C1C"/>
+                </a:solidFill>
+                <a:latin typeface="Segoe UI"/>
+                <a:ea typeface="Segoe UI"/>
+                <a:cs typeface="Segoe UI"/>
+              </a:rPr>
+              <a:t>1</a:t>
+            </a:r>
+            <a:endParaRPr sz="1400"/>
+          </a:p>
+        </p:txBody>
+      </p:sp>
+      <p:sp>
+        <p:nvSpPr>
+          <p:cNvPr id="34" name="Text 32">
+            <a:extLst xmlns:a="http://schemas.openxmlformats.org/drawingml/2006/main">
+              <a:ext uri="{FF2B5EF4-FFF2-40B4-BE49-F238E27FC236}">
+                <a16:creationId xmlns:a16="http://schemas.microsoft.com/office/drawing/2014/main" id="{238AC4CD-6D61-48DB-A517-D6307F2E37E6}"/>
+              </a:ext>
+            </a:extLst>
+          </p:cNvPr>
+          <p:cNvSpPr>
+            <a:spLocks xmlns:a="http://schemas.openxmlformats.org/drawingml/2006/main" noGrp="1"/>
+          </p:cNvSpPr>
+          <p:nvPr/>
+        </p:nvSpPr>
+        <p:spPr>
+          <a:xfrm xmlns:a="http://schemas.openxmlformats.org/drawingml/2006/main">
+            <a:off x="8924544" y="2551176"/>
+            <a:ext cx="2240280" cy="164592"/>
+          </a:xfrm>
+          <a:prstGeom xmlns:a="http://schemas.openxmlformats.org/drawingml/2006/main" prst="rect">
+            <a:avLst/>
+          </a:prstGeom>
+          <a:noFill xmlns:a="http://schemas.openxmlformats.org/drawingml/2006/main"/>
+        </p:spPr>
+        <p:txBody>
+          <a:bodyPr xmlns:a="http://schemas.openxmlformats.org/drawingml/2006/main" wrap="square" lIns="0" tIns="0" rIns="0" bIns="0" anchor="ctr"/>
+          <a:lstStyle xmlns:a="http://schemas.openxmlformats.org/drawingml/2006/main"/>
+          <a:p xmlns:a="http://schemas.openxmlformats.org/drawingml/2006/main">
+            <a:pPr marL="0" indent="0">
+              <a:buNone/>
+            </a:pPr>
+            <a:r>
+              <a:rPr sz="1040" b="1">
+                <a:solidFill>
+                  <a:srgbClr val="1C1C1C"/>
+                </a:solidFill>
+                <a:latin typeface="Segoe UI"/>
+                <a:ea typeface="Segoe UI"/>
+                <a:cs typeface="Segoe UI"/>
+              </a:rPr>
+              <a:t>Hands-free Q&amp;A</a:t>
+            </a:r>
+            <a:endParaRPr sz="1040"/>
+          </a:p>
+        </p:txBody>
+      </p:sp>
+      <p:sp>
+        <p:nvSpPr>
+          <p:cNvPr id="35" name="Text 33">
+            <a:extLst xmlns:a="http://schemas.openxmlformats.org/drawingml/2006/main">
+              <a:ext uri="{FF2B5EF4-FFF2-40B4-BE49-F238E27FC236}">
+                <a16:creationId xmlns:a16="http://schemas.microsoft.com/office/drawing/2014/main" id="{9C2C77B0-FD0B-492E-9684-8347E74BC14F}"/>
+              </a:ext>
+            </a:extLst>
+          </p:cNvPr>
+          <p:cNvSpPr>
+            <a:spLocks xmlns:a="http://schemas.openxmlformats.org/drawingml/2006/main" noGrp="1"/>
+          </p:cNvSpPr>
+          <p:nvPr/>
+        </p:nvSpPr>
+        <p:spPr>
+          <a:xfrm xmlns:a="http://schemas.openxmlformats.org/drawingml/2006/main">
+            <a:off x="8924544" y="2752344"/>
+            <a:ext cx="2286000" cy="201168"/>
+          </a:xfrm>
+          <a:prstGeom xmlns:a="http://schemas.openxmlformats.org/drawingml/2006/main" prst="rect">
+            <a:avLst/>
+          </a:prstGeom>
+          <a:noFill xmlns:a="http://schemas.openxmlformats.org/drawingml/2006/main"/>
+        </p:spPr>
+        <p:txBody>
+          <a:bodyPr xmlns:a="http://schemas.openxmlformats.org/drawingml/2006/main" wrap="square" lIns="0" tIns="0" rIns="0" bIns="0" anchor="ctr"/>
+          <a:lstStyle xmlns:a="http://schemas.openxmlformats.org/drawingml/2006/main"/>
+          <a:p xmlns:a="http://schemas.openxmlformats.org/drawingml/2006/main">
+            <a:pPr marL="0" indent="0">
+              <a:buNone/>
+            </a:pPr>
+            <a:r>
+              <a:rPr sz="860">
+                <a:solidFill>
+                  <a:srgbClr val="6B7280"/>
+                </a:solidFill>
+                <a:latin typeface="Segoe UI"/>
+                <a:ea typeface="Segoe UI"/>
+                <a:cs typeface="Segoe UI"/>
+              </a:rPr>
+              <a:t>Worker speaks while hands are occupied.</a:t>
+            </a:r>
+            <a:endParaRPr sz="860"/>
+          </a:p>
+        </p:txBody>
+      </p:sp>
+      <p:sp>
+        <p:nvSpPr>
+          <p:cNvPr id="36" name="Shape 34">
+            <a:extLst xmlns:a="http://schemas.openxmlformats.org/drawingml/2006/main">
+              <a:ext uri="{FF2B5EF4-FFF2-40B4-BE49-F238E27FC236}">
+                <a16:creationId xmlns:a16="http://schemas.microsoft.com/office/drawing/2014/main" id="{F60400B3-6A01-40F7-9538-A03DFB98D292}"/>
+              </a:ext>
+            </a:extLst>
+          </p:cNvPr>
+          <p:cNvSpPr>
+            <a:spLocks xmlns:a="http://schemas.openxmlformats.org/drawingml/2006/main" noGrp="1"/>
+          </p:cNvSpPr>
+          <p:nvPr/>
+        </p:nvSpPr>
+        <p:spPr>
+          <a:xfrm xmlns:a="http://schemas.openxmlformats.org/drawingml/2006/main">
+            <a:off x="8449056" y="3182112"/>
+            <a:ext cx="347472" cy="347472"/>
+          </a:xfrm>
+          <a:prstGeom xmlns:a="http://schemas.openxmlformats.org/drawingml/2006/main" prst="ellipse">
+            <a:avLst/>
+          </a:prstGeom>
+          <a:solidFill xmlns:a="http://schemas.openxmlformats.org/drawingml/2006/main">
+            <a:srgbClr val="3B82F6"/>
+          </a:solidFill>
+          <a:ln xmlns:a="http://schemas.openxmlformats.org/drawingml/2006/main" w="12700">
+            <a:solidFill>
+              <a:srgbClr val="3B82F6"/>
+            </a:solidFill>
+            <a:prstDash val="solid"/>
+          </a:ln>
+        </p:spPr>
+      </p:sp>
+      <p:sp>
+        <p:nvSpPr>
+          <p:cNvPr id="37" name="Text 35">
+            <a:extLst xmlns:a="http://schemas.openxmlformats.org/drawingml/2006/main">
+              <a:ext uri="{FF2B5EF4-FFF2-40B4-BE49-F238E27FC236}">
+                <a16:creationId xmlns:a16="http://schemas.microsoft.com/office/drawing/2014/main" id="{60244235-D192-49EC-8DC6-4797EC6C40C1}"/>
+              </a:ext>
+            </a:extLst>
+          </p:cNvPr>
+          <p:cNvSpPr>
+            <a:spLocks xmlns:a="http://schemas.openxmlformats.org/drawingml/2006/main" noGrp="1"/>
+          </p:cNvSpPr>
+          <p:nvPr/>
+        </p:nvSpPr>
+        <p:spPr>
+          <a:xfrm xmlns:a="http://schemas.openxmlformats.org/drawingml/2006/main">
+            <a:off x="8449056" y="3232404"/>
+            <a:ext cx="347472" cy="292608"/>
+          </a:xfrm>
+          <a:prstGeom xmlns:a="http://schemas.openxmlformats.org/drawingml/2006/main" prst="rect">
+            <a:avLst/>
+          </a:prstGeom>
+          <a:noFill xmlns:a="http://schemas.openxmlformats.org/drawingml/2006/main"/>
+        </p:spPr>
+        <p:txBody>
+          <a:bodyPr xmlns:a="http://schemas.openxmlformats.org/drawingml/2006/main" wrap="square" lIns="0" tIns="0" rIns="0" bIns="0" anchor="ctr"/>
+          <a:lstStyle xmlns:a="http://schemas.openxmlformats.org/drawingml/2006/main"/>
+          <a:p xmlns:a="http://schemas.openxmlformats.org/drawingml/2006/main">
+            <a:pPr marL="0" indent="0" algn="ctr">
+              <a:buNone/>
+            </a:pPr>
+            <a:r>
+              <a:rPr sz="1400" b="1">
+                <a:solidFill>
+                  <a:srgbClr val="1C1C1C"/>
+                </a:solidFill>
+                <a:latin typeface="Segoe UI"/>
+                <a:ea typeface="Segoe UI"/>
+                <a:cs typeface="Segoe UI"/>
+              </a:rPr>
+              <a:t>2</a:t>
+            </a:r>
+            <a:endParaRPr sz="1400"/>
+          </a:p>
+        </p:txBody>
+      </p:sp>
+      <p:sp>
+        <p:nvSpPr>
+          <p:cNvPr id="38" name="Text 36">
+            <a:extLst xmlns:a="http://schemas.openxmlformats.org/drawingml/2006/main">
+              <a:ext uri="{FF2B5EF4-FFF2-40B4-BE49-F238E27FC236}">
+                <a16:creationId xmlns:a16="http://schemas.microsoft.com/office/drawing/2014/main" id="{35EBEAAA-0F80-47A8-90C5-788D31929F73}"/>
+              </a:ext>
+            </a:extLst>
+          </p:cNvPr>
+          <p:cNvSpPr>
+            <a:spLocks xmlns:a="http://schemas.openxmlformats.org/drawingml/2006/main" noGrp="1"/>
+          </p:cNvSpPr>
+          <p:nvPr/>
+        </p:nvSpPr>
+        <p:spPr>
+          <a:xfrm xmlns:a="http://schemas.openxmlformats.org/drawingml/2006/main">
+            <a:off x="8924544" y="3154680"/>
+            <a:ext cx="2240280" cy="164592"/>
+          </a:xfrm>
+          <a:prstGeom xmlns:a="http://schemas.openxmlformats.org/drawingml/2006/main" prst="rect">
+            <a:avLst/>
+          </a:prstGeom>
+          <a:noFill xmlns:a="http://schemas.openxmlformats.org/drawingml/2006/main"/>
+        </p:spPr>
+        <p:txBody>
+          <a:bodyPr xmlns:a="http://schemas.openxmlformats.org/drawingml/2006/main" wrap="square" lIns="0" tIns="0" rIns="0" bIns="0" anchor="ctr"/>
+          <a:lstStyle xmlns:a="http://schemas.openxmlformats.org/drawingml/2006/main"/>
+          <a:p xmlns:a="http://schemas.openxmlformats.org/drawingml/2006/main">
+            <a:pPr marL="0" indent="0">
+              <a:buNone/>
+            </a:pPr>
+            <a:r>
+              <a:rPr sz="1040" b="1">
+                <a:solidFill>
+                  <a:srgbClr val="1C1C1C"/>
+                </a:solidFill>
+                <a:latin typeface="Segoe UI"/>
+                <a:ea typeface="Segoe UI"/>
+                <a:cs typeface="Segoe UI"/>
+              </a:rPr>
+              <a:t>Live context</a:t>
+            </a:r>
+            <a:endParaRPr sz="1040"/>
+          </a:p>
+        </p:txBody>
+      </p:sp>
+      <p:sp>
+        <p:nvSpPr>
+          <p:cNvPr id="39" name="Text 37">
+            <a:extLst xmlns:a="http://schemas.openxmlformats.org/drawingml/2006/main">
+              <a:ext uri="{FF2B5EF4-FFF2-40B4-BE49-F238E27FC236}">
+                <a16:creationId xmlns:a16="http://schemas.microsoft.com/office/drawing/2014/main" id="{78B1533C-CE3F-488B-B9A4-3F43DBD6F6CB}"/>
+              </a:ext>
+            </a:extLst>
+          </p:cNvPr>
+          <p:cNvSpPr>
+            <a:spLocks xmlns:a="http://schemas.openxmlformats.org/drawingml/2006/main" noGrp="1"/>
+          </p:cNvSpPr>
+          <p:nvPr/>
+        </p:nvSpPr>
+        <p:spPr>
+          <a:xfrm xmlns:a="http://schemas.openxmlformats.org/drawingml/2006/main">
+            <a:off x="8924544" y="3355848"/>
+            <a:ext cx="2286000" cy="201168"/>
+          </a:xfrm>
+          <a:prstGeom xmlns:a="http://schemas.openxmlformats.org/drawingml/2006/main" prst="rect">
+            <a:avLst/>
+          </a:prstGeom>
+          <a:noFill xmlns:a="http://schemas.openxmlformats.org/drawingml/2006/main"/>
+        </p:spPr>
+        <p:txBody>
+          <a:bodyPr xmlns:a="http://schemas.openxmlformats.org/drawingml/2006/main" wrap="square" lIns="0" tIns="0" rIns="0" bIns="0" anchor="ctr"/>
+          <a:lstStyle xmlns:a="http://schemas.openxmlformats.org/drawingml/2006/main"/>
+          <a:p xmlns:a="http://schemas.openxmlformats.org/drawingml/2006/main">
+            <a:pPr marL="0" indent="0">
+              <a:buNone/>
+            </a:pPr>
+            <a:r>
+              <a:rPr sz="860">
+                <a:solidFill>
+                  <a:srgbClr val="6B7280"/>
+                </a:solidFill>
+                <a:latin typeface="Segoe UI"/>
+                <a:ea typeface="Segoe UI"/>
+                <a:cs typeface="Segoe UI"/>
+              </a:rPr>
+              <a:t>Wind changes the operational answer.</a:t>
+            </a:r>
+            <a:endParaRPr sz="860"/>
+          </a:p>
+        </p:txBody>
+      </p:sp>
+      <p:sp>
+        <p:nvSpPr>
+          <p:cNvPr id="40" name="Shape 38">
+            <a:extLst xmlns:a="http://schemas.openxmlformats.org/drawingml/2006/main">
+              <a:ext uri="{FF2B5EF4-FFF2-40B4-BE49-F238E27FC236}">
+                <a16:creationId xmlns:a16="http://schemas.microsoft.com/office/drawing/2014/main" id="{335D7294-6D8B-470E-87CB-F4175B18E227}"/>
+              </a:ext>
+            </a:extLst>
+          </p:cNvPr>
+          <p:cNvSpPr>
+            <a:spLocks xmlns:a="http://schemas.openxmlformats.org/drawingml/2006/main" noGrp="1"/>
+          </p:cNvSpPr>
+          <p:nvPr/>
+        </p:nvSpPr>
+        <p:spPr>
+          <a:xfrm xmlns:a="http://schemas.openxmlformats.org/drawingml/2006/main">
+            <a:off x="8449056" y="3785616"/>
+            <a:ext cx="347472" cy="347472"/>
           </a:xfrm>
           <a:prstGeom xmlns:a="http://schemas.openxmlformats.org/drawingml/2006/main" prst="ellipse">
             <a:avLst/>
@@ -15805,22 +16228,22 @@
       </p:sp>
       <p:sp>
         <p:nvSpPr>
-          <p:cNvPr id="28" name="Text 26">
-            <a:extLst xmlns:a="http://schemas.openxmlformats.org/drawingml/2006/main">
-              <a:ext uri="{FF2B5EF4-FFF2-40B4-BE49-F238E27FC236}">
-                <a16:creationId xmlns:a16="http://schemas.microsoft.com/office/drawing/2014/main" id="{820E972F-4266-4CA5-9A65-4C446C7A6BF8}"/>
-              </a:ext>
-            </a:extLst>
-          </p:cNvPr>
-          <p:cNvSpPr>
-            <a:spLocks xmlns:a="http://schemas.openxmlformats.org/drawingml/2006/main" noGrp="1"/>
-          </p:cNvSpPr>
-          <p:nvPr/>
-        </p:nvSpPr>
-        <p:spPr>
-          <a:xfrm xmlns:a="http://schemas.openxmlformats.org/drawingml/2006/main">
-            <a:off x="5230368" y="5376672"/>
-            <a:ext cx="1097280" cy="320040"/>
+          <p:cNvPr id="41" name="Text 39">
+            <a:extLst xmlns:a="http://schemas.openxmlformats.org/drawingml/2006/main">
+              <a:ext uri="{FF2B5EF4-FFF2-40B4-BE49-F238E27FC236}">
+                <a16:creationId xmlns:a16="http://schemas.microsoft.com/office/drawing/2014/main" id="{6CB3D00C-7355-4FDF-BB43-141966D5D633}"/>
+              </a:ext>
+            </a:extLst>
+          </p:cNvPr>
+          <p:cNvSpPr>
+            <a:spLocks xmlns:a="http://schemas.openxmlformats.org/drawingml/2006/main" noGrp="1"/>
+          </p:cNvSpPr>
+          <p:nvPr/>
+        </p:nvSpPr>
+        <p:spPr>
+          <a:xfrm xmlns:a="http://schemas.openxmlformats.org/drawingml/2006/main">
+            <a:off x="8449056" y="3835908"/>
+            <a:ext cx="347472" cy="292608"/>
           </a:xfrm>
           <a:prstGeom xmlns:a="http://schemas.openxmlformats.org/drawingml/2006/main" prst="rect">
             <a:avLst/>
@@ -15835,7 +16258,7 @@
               <a:buNone/>
             </a:pPr>
             <a:r>
-              <a:rPr sz="2600" b="1">
+              <a:rPr sz="1400" b="1">
                 <a:solidFill>
                   <a:srgbClr val="1C1C1C"/>
                 </a:solidFill>
@@ -15843,111 +16266,91 @@
                 <a:ea typeface="Segoe UI"/>
                 <a:cs typeface="Segoe UI"/>
               </a:rPr>
-              <a:t>●</a:t>
-            </a:r>
-            <a:endParaRPr sz="2600"/>
-          </a:p>
-        </p:txBody>
-      </p:sp>
-      <p:sp>
-        <p:nvSpPr>
-          <p:cNvPr id="29" name="Shape 27">
-            <a:extLst xmlns:a="http://schemas.openxmlformats.org/drawingml/2006/main">
-              <a:ext uri="{FF2B5EF4-FFF2-40B4-BE49-F238E27FC236}">
-                <a16:creationId xmlns:a16="http://schemas.microsoft.com/office/drawing/2014/main" id="{C521195A-4086-4B61-933A-49EC20DC88BE}"/>
-              </a:ext>
-            </a:extLst>
-          </p:cNvPr>
-          <p:cNvSpPr>
-            <a:spLocks xmlns:a="http://schemas.openxmlformats.org/drawingml/2006/main" noGrp="1"/>
-          </p:cNvSpPr>
-          <p:nvPr/>
-        </p:nvSpPr>
-        <p:spPr>
-          <a:xfrm xmlns:a="http://schemas.openxmlformats.org/drawingml/2006/main">
-            <a:off x="5779008" y="5669280"/>
-            <a:ext cx="0" cy="320040"/>
-          </a:xfrm>
-          <a:prstGeom xmlns:a="http://schemas.openxmlformats.org/drawingml/2006/main" prst="line">
-            <a:avLst/>
-          </a:prstGeom>
-          <a:noFill xmlns:a="http://schemas.openxmlformats.org/drawingml/2006/main"/>
-          <a:ln xmlns:a="http://schemas.openxmlformats.org/drawingml/2006/main" w="38100">
-            <a:solidFill>
-              <a:srgbClr val="1C1C1C"/>
-            </a:solidFill>
-            <a:prstDash val="solid"/>
-          </a:ln>
-        </p:spPr>
-      </p:sp>
-      <p:sp>
-        <p:nvSpPr>
-          <p:cNvPr id="30" name="Shape 28">
-            <a:extLst xmlns:a="http://schemas.openxmlformats.org/drawingml/2006/main">
-              <a:ext uri="{FF2B5EF4-FFF2-40B4-BE49-F238E27FC236}">
-                <a16:creationId xmlns:a16="http://schemas.microsoft.com/office/drawing/2014/main" id="{F6637B3F-BF2C-45D2-85BE-80022973B1FC}"/>
-              </a:ext>
-            </a:extLst>
-          </p:cNvPr>
-          <p:cNvSpPr>
-            <a:spLocks xmlns:a="http://schemas.openxmlformats.org/drawingml/2006/main" noGrp="1"/>
-          </p:cNvSpPr>
-          <p:nvPr/>
-        </p:nvSpPr>
-        <p:spPr>
-          <a:xfrm xmlns:a="http://schemas.openxmlformats.org/drawingml/2006/main">
-            <a:off x="8165592" y="1901952"/>
-            <a:ext cx="3520440" cy="4306824"/>
-          </a:xfrm>
-          <a:prstGeom xmlns:a="http://schemas.openxmlformats.org/drawingml/2006/main" prst="roundRect">
-            <a:avLst>
-              <a:gd name="adj" fmla="val 3117"/>
-            </a:avLst>
-          </a:prstGeom>
-          <a:solidFill xmlns:a="http://schemas.openxmlformats.org/drawingml/2006/main">
-            <a:srgbClr val="F7F9FB"/>
-          </a:solidFill>
-          <a:ln xmlns:a="http://schemas.openxmlformats.org/drawingml/2006/main" w="10160">
-            <a:solidFill>
-              <a:srgbClr val="E1E4EA"/>
-            </a:solidFill>
-            <a:prstDash val="solid"/>
-          </a:ln>
-        </p:spPr>
-      </p:sp>
-      <p:sp>
-        <p:nvSpPr>
-          <p:cNvPr id="31" name="Text 29">
-            <a:extLst xmlns:a="http://schemas.openxmlformats.org/drawingml/2006/main">
-              <a:ext uri="{FF2B5EF4-FFF2-40B4-BE49-F238E27FC236}">
-                <a16:creationId xmlns:a16="http://schemas.microsoft.com/office/drawing/2014/main" id="{E9415021-1129-4F33-9689-D7381BE777ED}"/>
-              </a:ext>
-            </a:extLst>
-          </p:cNvPr>
-          <p:cNvSpPr>
-            <a:spLocks xmlns:a="http://schemas.openxmlformats.org/drawingml/2006/main" noGrp="1"/>
-          </p:cNvSpPr>
-          <p:nvPr/>
-        </p:nvSpPr>
-        <p:spPr>
-          <a:xfrm xmlns:a="http://schemas.openxmlformats.org/drawingml/2006/main">
-            <a:off x="8458200" y="2157984"/>
-            <a:ext cx="2926080" cy="219456"/>
-          </a:xfrm>
-          <a:prstGeom xmlns:a="http://schemas.openxmlformats.org/drawingml/2006/main" prst="rect">
-            <a:avLst/>
-          </a:prstGeom>
-          <a:noFill xmlns:a="http://schemas.openxmlformats.org/drawingml/2006/main"/>
-        </p:spPr>
-        <p:txBody>
-          <a:bodyPr xmlns:a="http://schemas.openxmlformats.org/drawingml/2006/main" wrap="square" lIns="0" tIns="0" rIns="0" bIns="0" anchor="ctr"/>
-          <a:lstStyle xmlns:a="http://schemas.openxmlformats.org/drawingml/2006/main"/>
-          <a:p xmlns:a="http://schemas.openxmlformats.org/drawingml/2006/main">
-            <a:pPr marL="0" indent="0" algn="ctr">
-              <a:buNone/>
-            </a:pPr>
-            <a:r>
-              <a:rPr sz="950" b="1">
+              <a:t>3</a:t>
+            </a:r>
+            <a:endParaRPr sz="1400"/>
+          </a:p>
+        </p:txBody>
+      </p:sp>
+      <p:sp>
+        <p:nvSpPr>
+          <p:cNvPr id="42" name="Text 40">
+            <a:extLst xmlns:a="http://schemas.openxmlformats.org/drawingml/2006/main">
+              <a:ext uri="{FF2B5EF4-FFF2-40B4-BE49-F238E27FC236}">
+                <a16:creationId xmlns:a16="http://schemas.microsoft.com/office/drawing/2014/main" id="{CA56368B-FA57-4699-BEF3-8D441F59494C}"/>
+              </a:ext>
+            </a:extLst>
+          </p:cNvPr>
+          <p:cNvSpPr>
+            <a:spLocks xmlns:a="http://schemas.openxmlformats.org/drawingml/2006/main" noGrp="1"/>
+          </p:cNvSpPr>
+          <p:nvPr/>
+        </p:nvSpPr>
+        <p:spPr>
+          <a:xfrm xmlns:a="http://schemas.openxmlformats.org/drawingml/2006/main">
+            <a:off x="8924544" y="3758184"/>
+            <a:ext cx="2240280" cy="164592"/>
+          </a:xfrm>
+          <a:prstGeom xmlns:a="http://schemas.openxmlformats.org/drawingml/2006/main" prst="rect">
+            <a:avLst/>
+          </a:prstGeom>
+          <a:noFill xmlns:a="http://schemas.openxmlformats.org/drawingml/2006/main"/>
+        </p:spPr>
+        <p:txBody>
+          <a:bodyPr xmlns:a="http://schemas.openxmlformats.org/drawingml/2006/main" wrap="square" lIns="0" tIns="0" rIns="0" bIns="0" anchor="ctr"/>
+          <a:lstStyle xmlns:a="http://schemas.openxmlformats.org/drawingml/2006/main"/>
+          <a:p xmlns:a="http://schemas.openxmlformats.org/drawingml/2006/main">
+            <a:pPr marL="0" indent="0">
+              <a:buNone/>
+            </a:pPr>
+            <a:r>
+              <a:rPr sz="1040" b="1">
+                <a:solidFill>
+                  <a:srgbClr val="1C1C1C"/>
+                </a:solidFill>
+                <a:latin typeface="Segoe UI"/>
+                <a:ea typeface="Segoe UI"/>
+                <a:cs typeface="Segoe UI"/>
+              </a:rPr>
+              <a:t>SOP overrides the web</a:t>
+            </a:r>
+            <a:endParaRPr sz="1040"/>
+          </a:p>
+        </p:txBody>
+      </p:sp>
+      <p:sp>
+        <p:nvSpPr>
+          <p:cNvPr id="43" name="Text 41">
+            <a:extLst xmlns:a="http://schemas.openxmlformats.org/drawingml/2006/main">
+              <a:ext uri="{FF2B5EF4-FFF2-40B4-BE49-F238E27FC236}">
+                <a16:creationId xmlns:a16="http://schemas.microsoft.com/office/drawing/2014/main" id="{2D3840B5-F111-46A7-92E0-F63558776661}"/>
+              </a:ext>
+            </a:extLst>
+          </p:cNvPr>
+          <p:cNvSpPr>
+            <a:spLocks xmlns:a="http://schemas.openxmlformats.org/drawingml/2006/main" noGrp="1"/>
+          </p:cNvSpPr>
+          <p:nvPr/>
+        </p:nvSpPr>
+        <p:spPr>
+          <a:xfrm xmlns:a="http://schemas.openxmlformats.org/drawingml/2006/main">
+            <a:off x="8924544" y="3959352"/>
+            <a:ext cx="2286000" cy="201168"/>
+          </a:xfrm>
+          <a:prstGeom xmlns:a="http://schemas.openxmlformats.org/drawingml/2006/main" prst="rect">
+            <a:avLst/>
+          </a:prstGeom>
+          <a:noFill xmlns:a="http://schemas.openxmlformats.org/drawingml/2006/main"/>
+        </p:spPr>
+        <p:txBody>
+          <a:bodyPr xmlns:a="http://schemas.openxmlformats.org/drawingml/2006/main" wrap="square" lIns="0" tIns="0" rIns="0" bIns="0" anchor="ctr"/>
+          <a:lstStyle xmlns:a="http://schemas.openxmlformats.org/drawingml/2006/main"/>
+          <a:p xmlns:a="http://schemas.openxmlformats.org/drawingml/2006/main">
+            <a:pPr marL="0" indent="0">
+              <a:buNone/>
+            </a:pPr>
+            <a:r>
+              <a:rPr sz="860">
                 <a:solidFill>
                   <a:srgbClr val="6B7280"/>
                 </a:solidFill>
@@ -15955,29 +16358,29 @@
                 <a:ea typeface="Segoe UI"/>
                 <a:cs typeface="Segoe UI"/>
               </a:rPr>
-              <a:t>WHAT THE DEMO PROVES</a:t>
-            </a:r>
-            <a:endParaRPr sz="950"/>
-          </a:p>
-        </p:txBody>
-      </p:sp>
-      <p:sp>
-        <p:nvSpPr>
-          <p:cNvPr id="32" name="Shape 30">
-            <a:extLst xmlns:a="http://schemas.openxmlformats.org/drawingml/2006/main">
-              <a:ext uri="{FF2B5EF4-FFF2-40B4-BE49-F238E27FC236}">
-                <a16:creationId xmlns:a16="http://schemas.microsoft.com/office/drawing/2014/main" id="{F6F8662F-E3F9-42AE-BC45-951FD79F33F0}"/>
-              </a:ext>
-            </a:extLst>
-          </p:cNvPr>
-          <p:cNvSpPr>
-            <a:spLocks xmlns:a="http://schemas.openxmlformats.org/drawingml/2006/main" noGrp="1"/>
-          </p:cNvSpPr>
-          <p:nvPr/>
-        </p:nvSpPr>
-        <p:spPr>
-          <a:xfrm xmlns:a="http://schemas.openxmlformats.org/drawingml/2006/main">
-            <a:off x="8449056" y="2578608"/>
+              <a:t>Meridian’s stricter threshold wins.</a:t>
+            </a:r>
+            <a:endParaRPr sz="860"/>
+          </a:p>
+        </p:txBody>
+      </p:sp>
+      <p:sp>
+        <p:nvSpPr>
+          <p:cNvPr id="44" name="Shape 42">
+            <a:extLst xmlns:a="http://schemas.openxmlformats.org/drawingml/2006/main">
+              <a:ext uri="{FF2B5EF4-FFF2-40B4-BE49-F238E27FC236}">
+                <a16:creationId xmlns:a16="http://schemas.microsoft.com/office/drawing/2014/main" id="{D34724E4-F22F-487B-BF7A-0FA72E60309D}"/>
+              </a:ext>
+            </a:extLst>
+          </p:cNvPr>
+          <p:cNvSpPr>
+            <a:spLocks xmlns:a="http://schemas.openxmlformats.org/drawingml/2006/main" noGrp="1"/>
+          </p:cNvSpPr>
+          <p:nvPr/>
+        </p:nvSpPr>
+        <p:spPr>
+          <a:xfrm xmlns:a="http://schemas.openxmlformats.org/drawingml/2006/main">
+            <a:off x="8449056" y="4389120"/>
             <a:ext cx="347472" cy="347472"/>
           </a:xfrm>
           <a:prstGeom xmlns:a="http://schemas.openxmlformats.org/drawingml/2006/main" prst="ellipse">
@@ -15996,21 +16399,21 @@
       </p:sp>
       <p:sp>
         <p:nvSpPr>
-          <p:cNvPr id="33" name="Text 31">
-            <a:extLst xmlns:a="http://schemas.openxmlformats.org/drawingml/2006/main">
-              <a:ext uri="{FF2B5EF4-FFF2-40B4-BE49-F238E27FC236}">
-                <a16:creationId xmlns:a16="http://schemas.microsoft.com/office/drawing/2014/main" id="{0980BE50-77E9-4901-B894-5DC224E3B570}"/>
-              </a:ext>
-            </a:extLst>
-          </p:cNvPr>
-          <p:cNvSpPr>
-            <a:spLocks xmlns:a="http://schemas.openxmlformats.org/drawingml/2006/main" noGrp="1"/>
-          </p:cNvSpPr>
-          <p:nvPr/>
-        </p:nvSpPr>
-        <p:spPr>
-          <a:xfrm xmlns:a="http://schemas.openxmlformats.org/drawingml/2006/main">
-            <a:off x="8449056" y="2628900"/>
+          <p:cNvPr id="45" name="Text 43">
+            <a:extLst xmlns:a="http://schemas.openxmlformats.org/drawingml/2006/main">
+              <a:ext uri="{FF2B5EF4-FFF2-40B4-BE49-F238E27FC236}">
+                <a16:creationId xmlns:a16="http://schemas.microsoft.com/office/drawing/2014/main" id="{A67987BB-831D-4A5C-90DC-8B6EB658044D}"/>
+              </a:ext>
+            </a:extLst>
+          </p:cNvPr>
+          <p:cNvSpPr>
+            <a:spLocks xmlns:a="http://schemas.openxmlformats.org/drawingml/2006/main" noGrp="1"/>
+          </p:cNvSpPr>
+          <p:nvPr/>
+        </p:nvSpPr>
+        <p:spPr>
+          <a:xfrm xmlns:a="http://schemas.openxmlformats.org/drawingml/2006/main">
+            <a:off x="8449056" y="4439412"/>
             <a:ext cx="347472" cy="292608"/>
           </a:xfrm>
           <a:prstGeom xmlns:a="http://schemas.openxmlformats.org/drawingml/2006/main" prst="rect">
@@ -16034,7 +16437,7 @@
                 <a:ea typeface="Segoe UI"/>
                 <a:cs typeface="Segoe UI"/>
               </a:rPr>
-              <a:t>1</a:t>
+              <a:t>4</a:t>
             </a:r>
             <a:endParaRPr sz="1400"/>
           </a:p>
@@ -16042,21 +16445,21 @@
       </p:sp>
       <p:sp>
         <p:nvSpPr>
-          <p:cNvPr id="34" name="Text 32">
-            <a:extLst xmlns:a="http://schemas.openxmlformats.org/drawingml/2006/main">
-              <a:ext uri="{FF2B5EF4-FFF2-40B4-BE49-F238E27FC236}">
-                <a16:creationId xmlns:a16="http://schemas.microsoft.com/office/drawing/2014/main" id="{238AC4CD-6D61-48DB-A517-D6307F2E37E6}"/>
-              </a:ext>
-            </a:extLst>
-          </p:cNvPr>
-          <p:cNvSpPr>
-            <a:spLocks xmlns:a="http://schemas.openxmlformats.org/drawingml/2006/main" noGrp="1"/>
-          </p:cNvSpPr>
-          <p:nvPr/>
-        </p:nvSpPr>
-        <p:spPr>
-          <a:xfrm xmlns:a="http://schemas.openxmlformats.org/drawingml/2006/main">
-            <a:off x="8924544" y="2551176"/>
+          <p:cNvPr id="46" name="Text 44">
+            <a:extLst xmlns:a="http://schemas.openxmlformats.org/drawingml/2006/main">
+              <a:ext uri="{FF2B5EF4-FFF2-40B4-BE49-F238E27FC236}">
+                <a16:creationId xmlns:a16="http://schemas.microsoft.com/office/drawing/2014/main" id="{4E30161D-1E44-409D-97C2-2FC5135B87A5}"/>
+              </a:ext>
+            </a:extLst>
+          </p:cNvPr>
+          <p:cNvSpPr>
+            <a:spLocks xmlns:a="http://schemas.openxmlformats.org/drawingml/2006/main" noGrp="1"/>
+          </p:cNvSpPr>
+          <p:nvPr/>
+        </p:nvSpPr>
+        <p:spPr>
+          <a:xfrm xmlns:a="http://schemas.openxmlformats.org/drawingml/2006/main">
+            <a:off x="8924544" y="4361688"/>
             <a:ext cx="2240280" cy="164592"/>
           </a:xfrm>
           <a:prstGeom xmlns:a="http://schemas.openxmlformats.org/drawingml/2006/main" prst="rect">
@@ -16080,7 +16483,7 @@
                 <a:ea typeface="Segoe UI"/>
                 <a:cs typeface="Segoe UI"/>
               </a:rPr>
-              <a:t>Hands-free Q&amp;A</a:t>
+              <a:t>Source named aloud</a:t>
             </a:r>
             <a:endParaRPr sz="1040"/>
           </a:p>
@@ -16088,21 +16491,21 @@
       </p:sp>
       <p:sp>
         <p:nvSpPr>
-          <p:cNvPr id="35" name="Text 33">
-            <a:extLst xmlns:a="http://schemas.openxmlformats.org/drawingml/2006/main">
-              <a:ext uri="{FF2B5EF4-FFF2-40B4-BE49-F238E27FC236}">
-                <a16:creationId xmlns:a16="http://schemas.microsoft.com/office/drawing/2014/main" id="{9C2C77B0-FD0B-492E-9684-8347E74BC14F}"/>
-              </a:ext>
-            </a:extLst>
-          </p:cNvPr>
-          <p:cNvSpPr>
-            <a:spLocks xmlns:a="http://schemas.openxmlformats.org/drawingml/2006/main" noGrp="1"/>
-          </p:cNvSpPr>
-          <p:nvPr/>
-        </p:nvSpPr>
-        <p:spPr>
-          <a:xfrm xmlns:a="http://schemas.openxmlformats.org/drawingml/2006/main">
-            <a:off x="8924544" y="2752344"/>
+          <p:cNvPr id="47" name="Text 45">
+            <a:extLst xmlns:a="http://schemas.openxmlformats.org/drawingml/2006/main">
+              <a:ext uri="{FF2B5EF4-FFF2-40B4-BE49-F238E27FC236}">
+                <a16:creationId xmlns:a16="http://schemas.microsoft.com/office/drawing/2014/main" id="{FEE30243-5291-4B36-B6B0-CA9495518FEF}"/>
+              </a:ext>
+            </a:extLst>
+          </p:cNvPr>
+          <p:cNvSpPr>
+            <a:spLocks xmlns:a="http://schemas.openxmlformats.org/drawingml/2006/main" noGrp="1"/>
+          </p:cNvSpPr>
+          <p:nvPr/>
+        </p:nvSpPr>
+        <p:spPr>
+          <a:xfrm xmlns:a="http://schemas.openxmlformats.org/drawingml/2006/main">
+            <a:off x="8924544" y="4562856"/>
             <a:ext cx="2286000" cy="201168"/>
           </a:xfrm>
           <a:prstGeom xmlns:a="http://schemas.openxmlformats.org/drawingml/2006/main" prst="rect">
@@ -16126,7 +16529,7 @@
                 <a:ea typeface="Segoe UI"/>
                 <a:cs typeface="Segoe UI"/>
               </a:rPr>
-              <a:t>Worker speaks while hands are occupied.</a:t>
+              <a:t>The answer states the exact document.</a:t>
             </a:r>
             <a:endParaRPr sz="860"/>
           </a:p>
@@ -16134,21 +16537,21 @@
       </p:sp>
       <p:sp>
         <p:nvSpPr>
-          <p:cNvPr id="36" name="Shape 34">
-            <a:extLst xmlns:a="http://schemas.openxmlformats.org/drawingml/2006/main">
-              <a:ext uri="{FF2B5EF4-FFF2-40B4-BE49-F238E27FC236}">
-                <a16:creationId xmlns:a16="http://schemas.microsoft.com/office/drawing/2014/main" id="{F60400B3-6A01-40F7-9538-A03DFB98D292}"/>
-              </a:ext>
-            </a:extLst>
-          </p:cNvPr>
-          <p:cNvSpPr>
-            <a:spLocks xmlns:a="http://schemas.openxmlformats.org/drawingml/2006/main" noGrp="1"/>
-          </p:cNvSpPr>
-          <p:nvPr/>
-        </p:nvSpPr>
-        <p:spPr>
-          <a:xfrm xmlns:a="http://schemas.openxmlformats.org/drawingml/2006/main">
-            <a:off x="8449056" y="3182112"/>
+          <p:cNvPr id="48" name="Shape 46">
+            <a:extLst xmlns:a="http://schemas.openxmlformats.org/drawingml/2006/main">
+              <a:ext uri="{FF2B5EF4-FFF2-40B4-BE49-F238E27FC236}">
+                <a16:creationId xmlns:a16="http://schemas.microsoft.com/office/drawing/2014/main" id="{874DBAF5-2DB4-4921-B1F3-11F7CA0F010A}"/>
+              </a:ext>
+            </a:extLst>
+          </p:cNvPr>
+          <p:cNvSpPr>
+            <a:spLocks xmlns:a="http://schemas.openxmlformats.org/drawingml/2006/main" noGrp="1"/>
+          </p:cNvSpPr>
+          <p:nvPr/>
+        </p:nvSpPr>
+        <p:spPr>
+          <a:xfrm xmlns:a="http://schemas.openxmlformats.org/drawingml/2006/main">
+            <a:off x="8449056" y="4992624"/>
             <a:ext cx="347472" cy="347472"/>
           </a:xfrm>
           <a:prstGeom xmlns:a="http://schemas.openxmlformats.org/drawingml/2006/main" prst="ellipse">
@@ -16167,519 +16570,6 @@
       </p:sp>
       <p:sp>
         <p:nvSpPr>
-          <p:cNvPr id="37" name="Text 35">
-            <a:extLst xmlns:a="http://schemas.openxmlformats.org/drawingml/2006/main">
-              <a:ext uri="{FF2B5EF4-FFF2-40B4-BE49-F238E27FC236}">
-                <a16:creationId xmlns:a16="http://schemas.microsoft.com/office/drawing/2014/main" id="{60244235-D192-49EC-8DC6-4797EC6C40C1}"/>
-              </a:ext>
-            </a:extLst>
-          </p:cNvPr>
-          <p:cNvSpPr>
-            <a:spLocks xmlns:a="http://schemas.openxmlformats.org/drawingml/2006/main" noGrp="1"/>
-          </p:cNvSpPr>
-          <p:nvPr/>
-        </p:nvSpPr>
-        <p:spPr>
-          <a:xfrm xmlns:a="http://schemas.openxmlformats.org/drawingml/2006/main">
-            <a:off x="8449056" y="3232404"/>
-            <a:ext cx="347472" cy="292608"/>
-          </a:xfrm>
-          <a:prstGeom xmlns:a="http://schemas.openxmlformats.org/drawingml/2006/main" prst="rect">
-            <a:avLst/>
-          </a:prstGeom>
-          <a:noFill xmlns:a="http://schemas.openxmlformats.org/drawingml/2006/main"/>
-        </p:spPr>
-        <p:txBody>
-          <a:bodyPr xmlns:a="http://schemas.openxmlformats.org/drawingml/2006/main" wrap="square" lIns="0" tIns="0" rIns="0" bIns="0" anchor="ctr"/>
-          <a:lstStyle xmlns:a="http://schemas.openxmlformats.org/drawingml/2006/main"/>
-          <a:p xmlns:a="http://schemas.openxmlformats.org/drawingml/2006/main">
-            <a:pPr marL="0" indent="0" algn="ctr">
-              <a:buNone/>
-            </a:pPr>
-            <a:r>
-              <a:rPr sz="1400" b="1">
-                <a:solidFill>
-                  <a:srgbClr val="1C1C1C"/>
-                </a:solidFill>
-                <a:latin typeface="Segoe UI"/>
-                <a:ea typeface="Segoe UI"/>
-                <a:cs typeface="Segoe UI"/>
-              </a:rPr>
-              <a:t>2</a:t>
-            </a:r>
-            <a:endParaRPr sz="1400"/>
-          </a:p>
-        </p:txBody>
-      </p:sp>
-      <p:sp>
-        <p:nvSpPr>
-          <p:cNvPr id="38" name="Text 36">
-            <a:extLst xmlns:a="http://schemas.openxmlformats.org/drawingml/2006/main">
-              <a:ext uri="{FF2B5EF4-FFF2-40B4-BE49-F238E27FC236}">
-                <a16:creationId xmlns:a16="http://schemas.microsoft.com/office/drawing/2014/main" id="{35EBEAAA-0F80-47A8-90C5-788D31929F73}"/>
-              </a:ext>
-            </a:extLst>
-          </p:cNvPr>
-          <p:cNvSpPr>
-            <a:spLocks xmlns:a="http://schemas.openxmlformats.org/drawingml/2006/main" noGrp="1"/>
-          </p:cNvSpPr>
-          <p:nvPr/>
-        </p:nvSpPr>
-        <p:spPr>
-          <a:xfrm xmlns:a="http://schemas.openxmlformats.org/drawingml/2006/main">
-            <a:off x="8924544" y="3154680"/>
-            <a:ext cx="2240280" cy="164592"/>
-          </a:xfrm>
-          <a:prstGeom xmlns:a="http://schemas.openxmlformats.org/drawingml/2006/main" prst="rect">
-            <a:avLst/>
-          </a:prstGeom>
-          <a:noFill xmlns:a="http://schemas.openxmlformats.org/drawingml/2006/main"/>
-        </p:spPr>
-        <p:txBody>
-          <a:bodyPr xmlns:a="http://schemas.openxmlformats.org/drawingml/2006/main" wrap="square" lIns="0" tIns="0" rIns="0" bIns="0" anchor="ctr"/>
-          <a:lstStyle xmlns:a="http://schemas.openxmlformats.org/drawingml/2006/main"/>
-          <a:p xmlns:a="http://schemas.openxmlformats.org/drawingml/2006/main">
-            <a:pPr marL="0" indent="0">
-              <a:buNone/>
-            </a:pPr>
-            <a:r>
-              <a:rPr sz="1040" b="1">
-                <a:solidFill>
-                  <a:srgbClr val="1C1C1C"/>
-                </a:solidFill>
-                <a:latin typeface="Segoe UI"/>
-                <a:ea typeface="Segoe UI"/>
-                <a:cs typeface="Segoe UI"/>
-              </a:rPr>
-              <a:t>Live context</a:t>
-            </a:r>
-            <a:endParaRPr sz="1040"/>
-          </a:p>
-        </p:txBody>
-      </p:sp>
-      <p:sp>
-        <p:nvSpPr>
-          <p:cNvPr id="39" name="Text 37">
-            <a:extLst xmlns:a="http://schemas.openxmlformats.org/drawingml/2006/main">
-              <a:ext uri="{FF2B5EF4-FFF2-40B4-BE49-F238E27FC236}">
-                <a16:creationId xmlns:a16="http://schemas.microsoft.com/office/drawing/2014/main" id="{78B1533C-CE3F-488B-B9A4-3F43DBD6F6CB}"/>
-              </a:ext>
-            </a:extLst>
-          </p:cNvPr>
-          <p:cNvSpPr>
-            <a:spLocks xmlns:a="http://schemas.openxmlformats.org/drawingml/2006/main" noGrp="1"/>
-          </p:cNvSpPr>
-          <p:nvPr/>
-        </p:nvSpPr>
-        <p:spPr>
-          <a:xfrm xmlns:a="http://schemas.openxmlformats.org/drawingml/2006/main">
-            <a:off x="8924544" y="3355848"/>
-            <a:ext cx="2286000" cy="201168"/>
-          </a:xfrm>
-          <a:prstGeom xmlns:a="http://schemas.openxmlformats.org/drawingml/2006/main" prst="rect">
-            <a:avLst/>
-          </a:prstGeom>
-          <a:noFill xmlns:a="http://schemas.openxmlformats.org/drawingml/2006/main"/>
-        </p:spPr>
-        <p:txBody>
-          <a:bodyPr xmlns:a="http://schemas.openxmlformats.org/drawingml/2006/main" wrap="square" lIns="0" tIns="0" rIns="0" bIns="0" anchor="ctr"/>
-          <a:lstStyle xmlns:a="http://schemas.openxmlformats.org/drawingml/2006/main"/>
-          <a:p xmlns:a="http://schemas.openxmlformats.org/drawingml/2006/main">
-            <a:pPr marL="0" indent="0">
-              <a:buNone/>
-            </a:pPr>
-            <a:r>
-              <a:rPr sz="860">
-                <a:solidFill>
-                  <a:srgbClr val="6B7280"/>
-                </a:solidFill>
-                <a:latin typeface="Segoe UI"/>
-                <a:ea typeface="Segoe UI"/>
-                <a:cs typeface="Segoe UI"/>
-              </a:rPr>
-              <a:t>Wind changes the operational answer.</a:t>
-            </a:r>
-            <a:endParaRPr sz="860"/>
-          </a:p>
-        </p:txBody>
-      </p:sp>
-      <p:sp>
-        <p:nvSpPr>
-          <p:cNvPr id="40" name="Shape 38">
-            <a:extLst xmlns:a="http://schemas.openxmlformats.org/drawingml/2006/main">
-              <a:ext uri="{FF2B5EF4-FFF2-40B4-BE49-F238E27FC236}">
-                <a16:creationId xmlns:a16="http://schemas.microsoft.com/office/drawing/2014/main" id="{335D7294-6D8B-470E-87CB-F4175B18E227}"/>
-              </a:ext>
-            </a:extLst>
-          </p:cNvPr>
-          <p:cNvSpPr>
-            <a:spLocks xmlns:a="http://schemas.openxmlformats.org/drawingml/2006/main" noGrp="1"/>
-          </p:cNvSpPr>
-          <p:nvPr/>
-        </p:nvSpPr>
-        <p:spPr>
-          <a:xfrm xmlns:a="http://schemas.openxmlformats.org/drawingml/2006/main">
-            <a:off x="8449056" y="3785616"/>
-            <a:ext cx="347472" cy="347472"/>
-          </a:xfrm>
-          <a:prstGeom xmlns:a="http://schemas.openxmlformats.org/drawingml/2006/main" prst="ellipse">
-            <a:avLst/>
-          </a:prstGeom>
-          <a:solidFill xmlns:a="http://schemas.openxmlformats.org/drawingml/2006/main">
-            <a:srgbClr val="F59E0B"/>
-          </a:solidFill>
-          <a:ln xmlns:a="http://schemas.openxmlformats.org/drawingml/2006/main" w="12700">
-            <a:solidFill>
-              <a:srgbClr val="F59E0B"/>
-            </a:solidFill>
-            <a:prstDash val="solid"/>
-          </a:ln>
-        </p:spPr>
-      </p:sp>
-      <p:sp>
-        <p:nvSpPr>
-          <p:cNvPr id="41" name="Text 39">
-            <a:extLst xmlns:a="http://schemas.openxmlformats.org/drawingml/2006/main">
-              <a:ext uri="{FF2B5EF4-FFF2-40B4-BE49-F238E27FC236}">
-                <a16:creationId xmlns:a16="http://schemas.microsoft.com/office/drawing/2014/main" id="{6CB3D00C-7355-4FDF-BB43-141966D5D633}"/>
-              </a:ext>
-            </a:extLst>
-          </p:cNvPr>
-          <p:cNvSpPr>
-            <a:spLocks xmlns:a="http://schemas.openxmlformats.org/drawingml/2006/main" noGrp="1"/>
-          </p:cNvSpPr>
-          <p:nvPr/>
-        </p:nvSpPr>
-        <p:spPr>
-          <a:xfrm xmlns:a="http://schemas.openxmlformats.org/drawingml/2006/main">
-            <a:off x="8449056" y="3835908"/>
-            <a:ext cx="347472" cy="292608"/>
-          </a:xfrm>
-          <a:prstGeom xmlns:a="http://schemas.openxmlformats.org/drawingml/2006/main" prst="rect">
-            <a:avLst/>
-          </a:prstGeom>
-          <a:noFill xmlns:a="http://schemas.openxmlformats.org/drawingml/2006/main"/>
-        </p:spPr>
-        <p:txBody>
-          <a:bodyPr xmlns:a="http://schemas.openxmlformats.org/drawingml/2006/main" wrap="square" lIns="0" tIns="0" rIns="0" bIns="0" anchor="ctr"/>
-          <a:lstStyle xmlns:a="http://schemas.openxmlformats.org/drawingml/2006/main"/>
-          <a:p xmlns:a="http://schemas.openxmlformats.org/drawingml/2006/main">
-            <a:pPr marL="0" indent="0" algn="ctr">
-              <a:buNone/>
-            </a:pPr>
-            <a:r>
-              <a:rPr sz="1400" b="1">
-                <a:solidFill>
-                  <a:srgbClr val="1C1C1C"/>
-                </a:solidFill>
-                <a:latin typeface="Segoe UI"/>
-                <a:ea typeface="Segoe UI"/>
-                <a:cs typeface="Segoe UI"/>
-              </a:rPr>
-              <a:t>3</a:t>
-            </a:r>
-            <a:endParaRPr sz="1400"/>
-          </a:p>
-        </p:txBody>
-      </p:sp>
-      <p:sp>
-        <p:nvSpPr>
-          <p:cNvPr id="42" name="Text 40">
-            <a:extLst xmlns:a="http://schemas.openxmlformats.org/drawingml/2006/main">
-              <a:ext uri="{FF2B5EF4-FFF2-40B4-BE49-F238E27FC236}">
-                <a16:creationId xmlns:a16="http://schemas.microsoft.com/office/drawing/2014/main" id="{CA56368B-FA57-4699-BEF3-8D441F59494C}"/>
-              </a:ext>
-            </a:extLst>
-          </p:cNvPr>
-          <p:cNvSpPr>
-            <a:spLocks xmlns:a="http://schemas.openxmlformats.org/drawingml/2006/main" noGrp="1"/>
-          </p:cNvSpPr>
-          <p:nvPr/>
-        </p:nvSpPr>
-        <p:spPr>
-          <a:xfrm xmlns:a="http://schemas.openxmlformats.org/drawingml/2006/main">
-            <a:off x="8924544" y="3758184"/>
-            <a:ext cx="2240280" cy="164592"/>
-          </a:xfrm>
-          <a:prstGeom xmlns:a="http://schemas.openxmlformats.org/drawingml/2006/main" prst="rect">
-            <a:avLst/>
-          </a:prstGeom>
-          <a:noFill xmlns:a="http://schemas.openxmlformats.org/drawingml/2006/main"/>
-        </p:spPr>
-        <p:txBody>
-          <a:bodyPr xmlns:a="http://schemas.openxmlformats.org/drawingml/2006/main" wrap="square" lIns="0" tIns="0" rIns="0" bIns="0" anchor="ctr"/>
-          <a:lstStyle xmlns:a="http://schemas.openxmlformats.org/drawingml/2006/main"/>
-          <a:p xmlns:a="http://schemas.openxmlformats.org/drawingml/2006/main">
-            <a:pPr marL="0" indent="0">
-              <a:buNone/>
-            </a:pPr>
-            <a:r>
-              <a:rPr sz="1040" b="1">
-                <a:solidFill>
-                  <a:srgbClr val="1C1C1C"/>
-                </a:solidFill>
-                <a:latin typeface="Segoe UI"/>
-                <a:ea typeface="Segoe UI"/>
-                <a:cs typeface="Segoe UI"/>
-              </a:rPr>
-              <a:t>SOP overrides the web</a:t>
-            </a:r>
-            <a:endParaRPr sz="1040"/>
-          </a:p>
-        </p:txBody>
-      </p:sp>
-      <p:sp>
-        <p:nvSpPr>
-          <p:cNvPr id="43" name="Text 41">
-            <a:extLst xmlns:a="http://schemas.openxmlformats.org/drawingml/2006/main">
-              <a:ext uri="{FF2B5EF4-FFF2-40B4-BE49-F238E27FC236}">
-                <a16:creationId xmlns:a16="http://schemas.microsoft.com/office/drawing/2014/main" id="{2D3840B5-F111-46A7-92E0-F63558776661}"/>
-              </a:ext>
-            </a:extLst>
-          </p:cNvPr>
-          <p:cNvSpPr>
-            <a:spLocks xmlns:a="http://schemas.openxmlformats.org/drawingml/2006/main" noGrp="1"/>
-          </p:cNvSpPr>
-          <p:nvPr/>
-        </p:nvSpPr>
-        <p:spPr>
-          <a:xfrm xmlns:a="http://schemas.openxmlformats.org/drawingml/2006/main">
-            <a:off x="8924544" y="3959352"/>
-            <a:ext cx="2286000" cy="201168"/>
-          </a:xfrm>
-          <a:prstGeom xmlns:a="http://schemas.openxmlformats.org/drawingml/2006/main" prst="rect">
-            <a:avLst/>
-          </a:prstGeom>
-          <a:noFill xmlns:a="http://schemas.openxmlformats.org/drawingml/2006/main"/>
-        </p:spPr>
-        <p:txBody>
-          <a:bodyPr xmlns:a="http://schemas.openxmlformats.org/drawingml/2006/main" wrap="square" lIns="0" tIns="0" rIns="0" bIns="0" anchor="ctr"/>
-          <a:lstStyle xmlns:a="http://schemas.openxmlformats.org/drawingml/2006/main"/>
-          <a:p xmlns:a="http://schemas.openxmlformats.org/drawingml/2006/main">
-            <a:pPr marL="0" indent="0">
-              <a:buNone/>
-            </a:pPr>
-            <a:r>
-              <a:rPr sz="860">
-                <a:solidFill>
-                  <a:srgbClr val="6B7280"/>
-                </a:solidFill>
-                <a:latin typeface="Segoe UI"/>
-                <a:ea typeface="Segoe UI"/>
-                <a:cs typeface="Segoe UI"/>
-              </a:rPr>
-              <a:t>Meridian’s stricter threshold wins.</a:t>
-            </a:r>
-            <a:endParaRPr sz="860"/>
-          </a:p>
-        </p:txBody>
-      </p:sp>
-      <p:sp>
-        <p:nvSpPr>
-          <p:cNvPr id="44" name="Shape 42">
-            <a:extLst xmlns:a="http://schemas.openxmlformats.org/drawingml/2006/main">
-              <a:ext uri="{FF2B5EF4-FFF2-40B4-BE49-F238E27FC236}">
-                <a16:creationId xmlns:a16="http://schemas.microsoft.com/office/drawing/2014/main" id="{D34724E4-F22F-487B-BF7A-0FA72E60309D}"/>
-              </a:ext>
-            </a:extLst>
-          </p:cNvPr>
-          <p:cNvSpPr>
-            <a:spLocks xmlns:a="http://schemas.openxmlformats.org/drawingml/2006/main" noGrp="1"/>
-          </p:cNvSpPr>
-          <p:nvPr/>
-        </p:nvSpPr>
-        <p:spPr>
-          <a:xfrm xmlns:a="http://schemas.openxmlformats.org/drawingml/2006/main">
-            <a:off x="8449056" y="4389120"/>
-            <a:ext cx="347472" cy="347472"/>
-          </a:xfrm>
-          <a:prstGeom xmlns:a="http://schemas.openxmlformats.org/drawingml/2006/main" prst="ellipse">
-            <a:avLst/>
-          </a:prstGeom>
-          <a:solidFill xmlns:a="http://schemas.openxmlformats.org/drawingml/2006/main">
-            <a:srgbClr val="3B82F6"/>
-          </a:solidFill>
-          <a:ln xmlns:a="http://schemas.openxmlformats.org/drawingml/2006/main" w="12700">
-            <a:solidFill>
-              <a:srgbClr val="3B82F6"/>
-            </a:solidFill>
-            <a:prstDash val="solid"/>
-          </a:ln>
-        </p:spPr>
-      </p:sp>
-      <p:sp>
-        <p:nvSpPr>
-          <p:cNvPr id="45" name="Text 43">
-            <a:extLst xmlns:a="http://schemas.openxmlformats.org/drawingml/2006/main">
-              <a:ext uri="{FF2B5EF4-FFF2-40B4-BE49-F238E27FC236}">
-                <a16:creationId xmlns:a16="http://schemas.microsoft.com/office/drawing/2014/main" id="{A67987BB-831D-4A5C-90DC-8B6EB658044D}"/>
-              </a:ext>
-            </a:extLst>
-          </p:cNvPr>
-          <p:cNvSpPr>
-            <a:spLocks xmlns:a="http://schemas.openxmlformats.org/drawingml/2006/main" noGrp="1"/>
-          </p:cNvSpPr>
-          <p:nvPr/>
-        </p:nvSpPr>
-        <p:spPr>
-          <a:xfrm xmlns:a="http://schemas.openxmlformats.org/drawingml/2006/main">
-            <a:off x="8449056" y="4439412"/>
-            <a:ext cx="347472" cy="292608"/>
-          </a:xfrm>
-          <a:prstGeom xmlns:a="http://schemas.openxmlformats.org/drawingml/2006/main" prst="rect">
-            <a:avLst/>
-          </a:prstGeom>
-          <a:noFill xmlns:a="http://schemas.openxmlformats.org/drawingml/2006/main"/>
-        </p:spPr>
-        <p:txBody>
-          <a:bodyPr xmlns:a="http://schemas.openxmlformats.org/drawingml/2006/main" wrap="square" lIns="0" tIns="0" rIns="0" bIns="0" anchor="ctr"/>
-          <a:lstStyle xmlns:a="http://schemas.openxmlformats.org/drawingml/2006/main"/>
-          <a:p xmlns:a="http://schemas.openxmlformats.org/drawingml/2006/main">
-            <a:pPr marL="0" indent="0" algn="ctr">
-              <a:buNone/>
-            </a:pPr>
-            <a:r>
-              <a:rPr sz="1400" b="1">
-                <a:solidFill>
-                  <a:srgbClr val="1C1C1C"/>
-                </a:solidFill>
-                <a:latin typeface="Segoe UI"/>
-                <a:ea typeface="Segoe UI"/>
-                <a:cs typeface="Segoe UI"/>
-              </a:rPr>
-              <a:t>4</a:t>
-            </a:r>
-            <a:endParaRPr sz="1400"/>
-          </a:p>
-        </p:txBody>
-      </p:sp>
-      <p:sp>
-        <p:nvSpPr>
-          <p:cNvPr id="46" name="Text 44">
-            <a:extLst xmlns:a="http://schemas.openxmlformats.org/drawingml/2006/main">
-              <a:ext uri="{FF2B5EF4-FFF2-40B4-BE49-F238E27FC236}">
-                <a16:creationId xmlns:a16="http://schemas.microsoft.com/office/drawing/2014/main" id="{4E30161D-1E44-409D-97C2-2FC5135B87A5}"/>
-              </a:ext>
-            </a:extLst>
-          </p:cNvPr>
-          <p:cNvSpPr>
-            <a:spLocks xmlns:a="http://schemas.openxmlformats.org/drawingml/2006/main" noGrp="1"/>
-          </p:cNvSpPr>
-          <p:nvPr/>
-        </p:nvSpPr>
-        <p:spPr>
-          <a:xfrm xmlns:a="http://schemas.openxmlformats.org/drawingml/2006/main">
-            <a:off x="8924544" y="4361688"/>
-            <a:ext cx="2240280" cy="164592"/>
-          </a:xfrm>
-          <a:prstGeom xmlns:a="http://schemas.openxmlformats.org/drawingml/2006/main" prst="rect">
-            <a:avLst/>
-          </a:prstGeom>
-          <a:noFill xmlns:a="http://schemas.openxmlformats.org/drawingml/2006/main"/>
-        </p:spPr>
-        <p:txBody>
-          <a:bodyPr xmlns:a="http://schemas.openxmlformats.org/drawingml/2006/main" wrap="square" lIns="0" tIns="0" rIns="0" bIns="0" anchor="ctr"/>
-          <a:lstStyle xmlns:a="http://schemas.openxmlformats.org/drawingml/2006/main"/>
-          <a:p xmlns:a="http://schemas.openxmlformats.org/drawingml/2006/main">
-            <a:pPr marL="0" indent="0">
-              <a:buNone/>
-            </a:pPr>
-            <a:r>
-              <a:rPr sz="1040" b="1">
-                <a:solidFill>
-                  <a:srgbClr val="1C1C1C"/>
-                </a:solidFill>
-                <a:latin typeface="Segoe UI"/>
-                <a:ea typeface="Segoe UI"/>
-                <a:cs typeface="Segoe UI"/>
-              </a:rPr>
-              <a:t>Source named aloud</a:t>
-            </a:r>
-            <a:endParaRPr sz="1040"/>
-          </a:p>
-        </p:txBody>
-      </p:sp>
-      <p:sp>
-        <p:nvSpPr>
-          <p:cNvPr id="47" name="Text 45">
-            <a:extLst xmlns:a="http://schemas.openxmlformats.org/drawingml/2006/main">
-              <a:ext uri="{FF2B5EF4-FFF2-40B4-BE49-F238E27FC236}">
-                <a16:creationId xmlns:a16="http://schemas.microsoft.com/office/drawing/2014/main" id="{FEE30243-5291-4B36-B6B0-CA9495518FEF}"/>
-              </a:ext>
-            </a:extLst>
-          </p:cNvPr>
-          <p:cNvSpPr>
-            <a:spLocks xmlns:a="http://schemas.openxmlformats.org/drawingml/2006/main" noGrp="1"/>
-          </p:cNvSpPr>
-          <p:nvPr/>
-        </p:nvSpPr>
-        <p:spPr>
-          <a:xfrm xmlns:a="http://schemas.openxmlformats.org/drawingml/2006/main">
-            <a:off x="8924544" y="4562856"/>
-            <a:ext cx="2286000" cy="201168"/>
-          </a:xfrm>
-          <a:prstGeom xmlns:a="http://schemas.openxmlformats.org/drawingml/2006/main" prst="rect">
-            <a:avLst/>
-          </a:prstGeom>
-          <a:noFill xmlns:a="http://schemas.openxmlformats.org/drawingml/2006/main"/>
-        </p:spPr>
-        <p:txBody>
-          <a:bodyPr xmlns:a="http://schemas.openxmlformats.org/drawingml/2006/main" wrap="square" lIns="0" tIns="0" rIns="0" bIns="0" anchor="ctr"/>
-          <a:lstStyle xmlns:a="http://schemas.openxmlformats.org/drawingml/2006/main"/>
-          <a:p xmlns:a="http://schemas.openxmlformats.org/drawingml/2006/main">
-            <a:pPr marL="0" indent="0">
-              <a:buNone/>
-            </a:pPr>
-            <a:r>
-              <a:rPr sz="860">
-                <a:solidFill>
-                  <a:srgbClr val="6B7280"/>
-                </a:solidFill>
-                <a:latin typeface="Segoe UI"/>
-                <a:ea typeface="Segoe UI"/>
-                <a:cs typeface="Segoe UI"/>
-              </a:rPr>
-              <a:t>The answer states the exact document.</a:t>
-            </a:r>
-            <a:endParaRPr sz="860"/>
-          </a:p>
-        </p:txBody>
-      </p:sp>
-      <p:sp>
-        <p:nvSpPr>
-          <p:cNvPr id="48" name="Shape 46">
-            <a:extLst xmlns:a="http://schemas.openxmlformats.org/drawingml/2006/main">
-              <a:ext uri="{FF2B5EF4-FFF2-40B4-BE49-F238E27FC236}">
-                <a16:creationId xmlns:a16="http://schemas.microsoft.com/office/drawing/2014/main" id="{874DBAF5-2DB4-4921-B1F3-11F7CA0F010A}"/>
-              </a:ext>
-            </a:extLst>
-          </p:cNvPr>
-          <p:cNvSpPr>
-            <a:spLocks xmlns:a="http://schemas.openxmlformats.org/drawingml/2006/main" noGrp="1"/>
-          </p:cNvSpPr>
-          <p:nvPr/>
-        </p:nvSpPr>
-        <p:spPr>
-          <a:xfrm xmlns:a="http://schemas.openxmlformats.org/drawingml/2006/main">
-            <a:off x="8449056" y="4992624"/>
-            <a:ext cx="347472" cy="347472"/>
-          </a:xfrm>
-          <a:prstGeom xmlns:a="http://schemas.openxmlformats.org/drawingml/2006/main" prst="ellipse">
-            <a:avLst/>
-          </a:prstGeom>
-          <a:solidFill xmlns:a="http://schemas.openxmlformats.org/drawingml/2006/main">
-            <a:srgbClr val="3B82F6"/>
-          </a:solidFill>
-          <a:ln xmlns:a="http://schemas.openxmlformats.org/drawingml/2006/main" w="12700">
-            <a:solidFill>
-              <a:srgbClr val="3B82F6"/>
-            </a:solidFill>
-            <a:prstDash val="solid"/>
-          </a:ln>
-        </p:spPr>
-      </p:sp>
-      <p:sp>
-        <p:nvSpPr>
           <p:cNvPr id="49" name="Text 47">
             <a:extLst xmlns:a="http://schemas.openxmlformats.org/drawingml/2006/main">
               <a:ext uri="{FF2B5EF4-FFF2-40B4-BE49-F238E27FC236}">
@@ -17041,14 +16931,14 @@
       </p:sp>
       <p:pic>
         <p:nvPicPr>
-          <p:cNvPr id="108" name=""/>
+          <p:cNvPr id="105" name=""/>
           <p:cNvPicPr>
             <a:picLocks xmlns:a="http://schemas.openxmlformats.org/drawingml/2006/main" noChangeAspect="1"/>
           </p:cNvPicPr>
           <p:nvPr/>
         </p:nvPicPr>
         <p:blipFill>
-          <a:blip xmlns:r="http://schemas.openxmlformats.org/officeDocument/2006/relationships" xmlns:a="http://schemas.openxmlformats.org/drawingml/2006/main" r:embed="R78ebe97146fc4fbf"/>
+          <a:blip xmlns:r="http://schemas.openxmlformats.org/officeDocument/2006/relationships" xmlns:a="http://schemas.openxmlformats.org/drawingml/2006/main" r:embed="Re77ad30bb2e649ce"/>
           <a:stretch xmlns:a="http://schemas.openxmlformats.org/drawingml/2006/main"/>
         </p:blipFill>
         <p:spPr>
@@ -18480,7 +18370,7 @@
           <p:nvPr/>
         </p:nvPicPr>
         <p:blipFill>
-          <a:blip xmlns:r="http://schemas.openxmlformats.org/officeDocument/2006/relationships" xmlns:a="http://schemas.openxmlformats.org/drawingml/2006/main" r:embed="R5df931b87090425a"/>
+          <a:blip xmlns:r="http://schemas.openxmlformats.org/officeDocument/2006/relationships" xmlns:a="http://schemas.openxmlformats.org/drawingml/2006/main" r:embed="Re54811eedcbb446e"/>
           <a:stretch xmlns:a="http://schemas.openxmlformats.org/drawingml/2006/main"/>
         </p:blipFill>
         <p:spPr>

</xml_diff>